<commit_message>
Enhance client docs: full-width layout, more detail, worked examples
- HTML (APIX overview + Responsible AI): switch centered narrow column to a
  full-width layout with a fixed left contents sidebar and wide content area
  that fills the page; add "New here? start" orientation boxes, two-column
  explanation+example sections, and concrete worked examples throughout.
- PPT (metrics + Responsible AI): add worked-example slides written for a
  newcomer — "how to read a KPI" (one call -> count), a golden-record example,
  and a fairness-check example.

Co-Authored-By: Claude Opus 4.8 (1M context) <noreply@anthropic.com>
</commit_message>
<xml_diff>
--- a/usecases/ai_pipeline 2/docs/APIX_Metrics_Discussion.pptx
+++ b/usecases/ai_pipeline 2/docs/APIX_Metrics_Discussion.pptx
@@ -14,6 +14,8 @@
     <p:sldId id="262" r:id="rId13"/>
     <p:sldId id="263" r:id="rId14"/>
     <p:sldId id="264" r:id="rId15"/>
+    <p:sldId id="265" r:id="rId16"/>
+    <p:sldId id="266" r:id="rId17"/>
   </p:sldIdLst>
   <p:sldSz cx="12191695" cy="6858000" type="screen4x3"/>
   <p:notesSz cx="6858000" cy="9144000"/>
@@ -3281,6 +3283,1009 @@
 </p:sld>
 </file>
 
+<file path=ppt/slides/slide10.xml><?xml version="1.0" encoding="utf-8"?>
+<p:sld xmlns:a="http://schemas.openxmlformats.org/drawingml/2006/main" xmlns:p="http://schemas.openxmlformats.org/presentationml/2006/main" xmlns:r="http://schemas.openxmlformats.org/officeDocument/2006/relationships">
+  <p:cSld>
+    <p:bg>
+      <p:bgPr>
+        <a:solidFill>
+          <a:srgbClr val="FFFFFF"/>
+        </a:solidFill>
+        <a:effectLst/>
+      </p:bgPr>
+    </p:bg>
+    <p:spTree>
+      <p:nvGrpSpPr>
+        <p:cNvPr id="1" name=""/>
+        <p:cNvGrpSpPr/>
+        <p:nvPr/>
+      </p:nvGrpSpPr>
+      <p:grpSpPr/>
+      <p:sp>
+        <p:nvSpPr>
+          <p:cNvPr id="2" name="Rectangle 1"/>
+          <p:cNvSpPr/>
+          <p:nvPr/>
+        </p:nvSpPr>
+        <p:spPr>
+          <a:xfrm>
+            <a:off x="0" y="0"/>
+            <a:ext cx="12191695" cy="128016"/>
+          </a:xfrm>
+          <a:prstGeom prst="rect">
+            <a:avLst/>
+          </a:prstGeom>
+          <a:solidFill>
+            <a:srgbClr val="0E7C74"/>
+          </a:solidFill>
+          <a:ln>
+            <a:noFill/>
+          </a:ln>
+        </p:spPr>
+        <p:style>
+          <a:lnRef idx="1">
+            <a:schemeClr val="accent1"/>
+          </a:lnRef>
+          <a:fillRef idx="3">
+            <a:schemeClr val="accent1"/>
+          </a:fillRef>
+          <a:effectRef idx="2">
+            <a:schemeClr val="accent1"/>
+          </a:effectRef>
+          <a:fontRef idx="minor">
+            <a:schemeClr val="lt1"/>
+          </a:fontRef>
+        </p:style>
+        <p:txBody>
+          <a:bodyPr rtlCol="0" anchor="ctr"/>
+          <a:lstStyle/>
+          <a:p>
+            <a:pPr algn="ctr"/>
+          </a:p>
+        </p:txBody>
+      </p:sp>
+      <p:sp>
+        <p:nvSpPr>
+          <p:cNvPr id="3" name="TextBox 2"/>
+          <p:cNvSpPr txBox="1"/>
+          <p:nvPr/>
+        </p:nvSpPr>
+        <p:spPr>
+          <a:xfrm>
+            <a:off x="640080" y="384048"/>
+            <a:ext cx="11155680" cy="1280160"/>
+          </a:xfrm>
+          <a:prstGeom prst="rect">
+            <a:avLst/>
+          </a:prstGeom>
+          <a:noFill/>
+        </p:spPr>
+        <p:txBody>
+          <a:bodyPr wrap="square">
+            <a:spAutoFit/>
+          </a:bodyPr>
+          <a:lstStyle/>
+          <a:p>
+            <a:pPr>
+              <a:spcAft>
+                <a:spcPts val="500"/>
+              </a:spcAft>
+            </a:pPr>
+            <a:r>
+              <a:rPr sz="1250" b="1">
+                <a:solidFill>
+                  <a:srgbClr val="0E7C74"/>
+                </a:solidFill>
+                <a:latin typeface="Segoe UI"/>
+              </a:rPr>
+              <a:t>WORKED EXAMPLE</a:t>
+            </a:r>
+          </a:p>
+          <a:p>
+            <a:pPr>
+              <a:spcAft>
+                <a:spcPts val="0"/>
+              </a:spcAft>
+            </a:pPr>
+            <a:r>
+              <a:rPr sz="2700" b="1">
+                <a:solidFill>
+                  <a:srgbClr val="1A1F27"/>
+                </a:solidFill>
+                <a:latin typeface="Segoe UI"/>
+              </a:rPr>
+              <a:t>How to read a KPI — from one call to a number</a:t>
+            </a:r>
+          </a:p>
+        </p:txBody>
+      </p:sp>
+      <p:sp>
+        <p:nvSpPr>
+          <p:cNvPr id="4" name="TextBox 3"/>
+          <p:cNvSpPr txBox="1"/>
+          <p:nvPr/>
+        </p:nvSpPr>
+        <p:spPr>
+          <a:xfrm>
+            <a:off x="685800" y="1600200"/>
+            <a:ext cx="10881360" cy="548640"/>
+          </a:xfrm>
+          <a:prstGeom prst="rect">
+            <a:avLst/>
+          </a:prstGeom>
+          <a:noFill/>
+        </p:spPr>
+        <p:txBody>
+          <a:bodyPr wrap="square">
+            <a:spAutoFit/>
+          </a:bodyPr>
+          <a:lstStyle/>
+          <a:p>
+            <a:pPr>
+              <a:spcAft>
+                <a:spcPts val="0"/>
+              </a:spcAft>
+            </a:pPr>
+            <a:r>
+              <a:rPr sz="1500" b="0">
+                <a:solidFill>
+                  <a:srgbClr val="535C6A"/>
+                </a:solidFill>
+                <a:latin typeface="Segoe UI"/>
+              </a:rPr>
+              <a:t>The AI judges each call; a KPI is simply those judgments added up per agent. No extra labelling.</a:t>
+            </a:r>
+          </a:p>
+        </p:txBody>
+      </p:sp>
+      <p:graphicFrame>
+        <p:nvGraphicFramePr>
+          <p:cNvPr id="5" name="Table 4"/>
+          <p:cNvGraphicFramePr>
+            <a:graphicFrameLocks noGrp="1"/>
+          </p:cNvGraphicFramePr>
+          <p:nvPr/>
+        </p:nvGraphicFramePr>
+        <p:xfrm>
+          <a:off x="640080" y="2194560"/>
+          <a:ext cx="10927080" cy="3291840"/>
+        </p:xfrm>
+        <a:graphic>
+          <a:graphicData uri="http://schemas.openxmlformats.org/drawingml/2006/table">
+            <a:tbl>
+              <a:tblPr firstRow="1">
+                <a:tableStyleId>{5C22544A-7EE6-4342-B048-85BDC9FD1C3A}</a:tableStyleId>
+              </a:tblPr>
+              <a:tblGrid>
+                <a:gridCol w="3017520"/>
+                <a:gridCol w="7909560"/>
+              </a:tblGrid>
+              <a:tr h="658368">
+                <a:tc>
+                  <a:txBody>
+                    <a:bodyPr wrap="square"/>
+                    <a:lstStyle/>
+                    <a:p>
+                      <a:r>
+                        <a:rPr sz="1100" b="1">
+                          <a:solidFill>
+                            <a:srgbClr val="FFFFFF"/>
+                          </a:solidFill>
+                          <a:latin typeface="Segoe UI"/>
+                        </a:rPr>
+                        <a:t>Step</a:t>
+                      </a:r>
+                    </a:p>
+                  </a:txBody>
+                  <a:tcPr anchor="ctr" marL="82296" marR="54864" marT="18288" marB="18288">
+                    <a:solidFill>
+                      <a:srgbClr val="0E7C74"/>
+                    </a:solidFill>
+                  </a:tcPr>
+                </a:tc>
+                <a:tc>
+                  <a:txBody>
+                    <a:bodyPr wrap="square"/>
+                    <a:lstStyle/>
+                    <a:p>
+                      <a:r>
+                        <a:rPr sz="1100" b="1">
+                          <a:solidFill>
+                            <a:srgbClr val="FFFFFF"/>
+                          </a:solidFill>
+                          <a:latin typeface="Segoe UI"/>
+                        </a:rPr>
+                        <a:t>What happens</a:t>
+                      </a:r>
+                    </a:p>
+                  </a:txBody>
+                  <a:tcPr anchor="ctr" marL="82296" marR="54864" marT="18288" marB="18288">
+                    <a:solidFill>
+                      <a:srgbClr val="0E7C74"/>
+                    </a:solidFill>
+                  </a:tcPr>
+                </a:tc>
+              </a:tr>
+              <a:tr h="658368">
+                <a:tc>
+                  <a:txBody>
+                    <a:bodyPr wrap="square"/>
+                    <a:lstStyle/>
+                    <a:p>
+                      <a:r>
+                        <a:rPr sz="1350" b="1">
+                          <a:solidFill>
+                            <a:srgbClr val="1A1F27"/>
+                          </a:solidFill>
+                          <a:latin typeface="Segoe UI"/>
+                        </a:rPr>
+                        <a:t>1 · The AI reads a call</a:t>
+                      </a:r>
+                    </a:p>
+                  </a:txBody>
+                  <a:tcPr anchor="ctr" marL="82296" marR="54864" marT="18288" marB="18288">
+                    <a:solidFill>
+                      <a:srgbClr val="FFFFFF"/>
+                    </a:solidFill>
+                  </a:tcPr>
+                </a:tc>
+                <a:tc>
+                  <a:txBody>
+                    <a:bodyPr wrap="square"/>
+                    <a:lstStyle/>
+                    <a:p>
+                      <a:r>
+                        <a:rPr sz="1350" b="0">
+                          <a:solidFill>
+                            <a:srgbClr val="535C6A"/>
+                          </a:solidFill>
+                          <a:latin typeface="Segoe UI"/>
+                        </a:rPr>
+                        <a:t>Notes: a new-line opportunity existed, the agent pitched, the issue was resolved</a:t>
+                      </a:r>
+                    </a:p>
+                  </a:txBody>
+                  <a:tcPr anchor="ctr" marL="82296" marR="54864" marT="18288" marB="18288">
+                    <a:solidFill>
+                      <a:srgbClr val="FFFFFF"/>
+                    </a:solidFill>
+                  </a:tcPr>
+                </a:tc>
+              </a:tr>
+              <a:tr h="658368">
+                <a:tc>
+                  <a:txBody>
+                    <a:bodyPr wrap="square"/>
+                    <a:lstStyle/>
+                    <a:p>
+                      <a:r>
+                        <a:rPr sz="1350" b="1">
+                          <a:solidFill>
+                            <a:srgbClr val="1A1F27"/>
+                          </a:solidFill>
+                          <a:latin typeface="Segoe UI"/>
+                        </a:rPr>
+                        <a:t>2 · Repeat for the week</a:t>
+                      </a:r>
+                    </a:p>
+                  </a:txBody>
+                  <a:tcPr anchor="ctr" marL="82296" marR="54864" marT="18288" marB="18288">
+                    <a:solidFill>
+                      <a:srgbClr val="F7F9F8"/>
+                    </a:solidFill>
+                  </a:tcPr>
+                </a:tc>
+                <a:tc>
+                  <a:txBody>
+                    <a:bodyPr wrap="square"/>
+                    <a:lstStyle/>
+                    <a:p>
+                      <a:r>
+                        <a:rPr sz="1350" b="0">
+                          <a:solidFill>
+                            <a:srgbClr val="535C6A"/>
+                          </a:solidFill>
+                          <a:latin typeface="Segoe UI"/>
+                        </a:rPr>
+                        <a:t>20 calls had a new-line opportunity; the agent pitched on 12 of them</a:t>
+                      </a:r>
+                    </a:p>
+                  </a:txBody>
+                  <a:tcPr anchor="ctr" marL="82296" marR="54864" marT="18288" marB="18288">
+                    <a:solidFill>
+                      <a:srgbClr val="F7F9F8"/>
+                    </a:solidFill>
+                  </a:tcPr>
+                </a:tc>
+              </a:tr>
+              <a:tr h="658368">
+                <a:tc>
+                  <a:txBody>
+                    <a:bodyPr wrap="square"/>
+                    <a:lstStyle/>
+                    <a:p>
+                      <a:r>
+                        <a:rPr sz="1350" b="1">
+                          <a:solidFill>
+                            <a:srgbClr val="1A1F27"/>
+                          </a:solidFill>
+                          <a:latin typeface="Segoe UI"/>
+                        </a:rPr>
+                        <a:t>3 · Count (no AI)</a:t>
+                      </a:r>
+                    </a:p>
+                  </a:txBody>
+                  <a:tcPr anchor="ctr" marL="82296" marR="54864" marT="18288" marB="18288">
+                    <a:solidFill>
+                      <a:srgbClr val="FFFFFF"/>
+                    </a:solidFill>
+                  </a:tcPr>
+                </a:tc>
+                <a:tc>
+                  <a:txBody>
+                    <a:bodyPr wrap="square"/>
+                    <a:lstStyle/>
+                    <a:p>
+                      <a:r>
+                        <a:rPr sz="1350" b="0">
+                          <a:solidFill>
+                            <a:srgbClr val="535C6A"/>
+                          </a:solidFill>
+                          <a:latin typeface="Segoe UI"/>
+                        </a:rPr>
+                        <a:t>new_line_pitches = 12</a:t>
+                      </a:r>
+                    </a:p>
+                  </a:txBody>
+                  <a:tcPr anchor="ctr" marL="82296" marR="54864" marT="18288" marB="18288">
+                    <a:solidFill>
+                      <a:srgbClr val="FFFFFF"/>
+                    </a:solidFill>
+                  </a:tcPr>
+                </a:tc>
+              </a:tr>
+              <a:tr h="658368">
+                <a:tc>
+                  <a:txBody>
+                    <a:bodyPr wrap="square"/>
+                    <a:lstStyle/>
+                    <a:p>
+                      <a:r>
+                        <a:rPr sz="1350" b="1">
+                          <a:solidFill>
+                            <a:srgbClr val="1A1F27"/>
+                          </a:solidFill>
+                          <a:latin typeface="Segoe UI"/>
+                        </a:rPr>
+                        <a:t>4 · Derive the rate</a:t>
+                      </a:r>
+                    </a:p>
+                  </a:txBody>
+                  <a:tcPr anchor="ctr" marL="82296" marR="54864" marT="18288" marB="18288">
+                    <a:solidFill>
+                      <a:srgbClr val="F7F9F8"/>
+                    </a:solidFill>
+                  </a:tcPr>
+                </a:tc>
+                <a:tc>
+                  <a:txBody>
+                    <a:bodyPr wrap="square"/>
+                    <a:lstStyle/>
+                    <a:p>
+                      <a:r>
+                        <a:rPr sz="1350" b="0">
+                          <a:solidFill>
+                            <a:srgbClr val="535C6A"/>
+                          </a:solidFill>
+                          <a:latin typeface="Segoe UI"/>
+                        </a:rPr>
+                        <a:t>opportunity_missed = 8 / 20 = 40%</a:t>
+                      </a:r>
+                    </a:p>
+                  </a:txBody>
+                  <a:tcPr anchor="ctr" marL="82296" marR="54864" marT="18288" marB="18288">
+                    <a:solidFill>
+                      <a:srgbClr val="F7F9F8"/>
+                    </a:solidFill>
+                  </a:tcPr>
+                </a:tc>
+              </a:tr>
+            </a:tbl>
+          </a:graphicData>
+        </a:graphic>
+      </p:graphicFrame>
+      <p:sp>
+        <p:nvSpPr>
+          <p:cNvPr id="6" name="Rectangle 5"/>
+          <p:cNvSpPr/>
+          <p:nvPr/>
+        </p:nvSpPr>
+        <p:spPr>
+          <a:xfrm>
+            <a:off x="685800" y="5806440"/>
+            <a:ext cx="10881360" cy="777240"/>
+          </a:xfrm>
+          <a:prstGeom prst="rect">
+            <a:avLst/>
+          </a:prstGeom>
+          <a:solidFill>
+            <a:srgbClr val="F2F5F4"/>
+          </a:solidFill>
+          <a:ln>
+            <a:noFill/>
+          </a:ln>
+        </p:spPr>
+        <p:style>
+          <a:lnRef idx="1">
+            <a:schemeClr val="accent1"/>
+          </a:lnRef>
+          <a:fillRef idx="3">
+            <a:schemeClr val="accent1"/>
+          </a:fillRef>
+          <a:effectRef idx="2">
+            <a:schemeClr val="accent1"/>
+          </a:effectRef>
+          <a:fontRef idx="minor">
+            <a:schemeClr val="lt1"/>
+          </a:fontRef>
+        </p:style>
+        <p:txBody>
+          <a:bodyPr rtlCol="0" anchor="ctr" wrap="square" lIns="228600" rIns="228600"/>
+          <a:lstStyle/>
+          <a:p>
+            <a:pPr algn="ctr">
+              <a:spcAft>
+                <a:spcPts val="0"/>
+              </a:spcAft>
+            </a:pPr>
+            <a:r>
+              <a:rPr sz="1600" b="1">
+                <a:solidFill>
+                  <a:srgbClr val="0E7C74"/>
+                </a:solidFill>
+                <a:latin typeface="Segoe UI"/>
+              </a:rPr>
+              <a:t>Every judgment also links to the exact call moments behind it — so any score can be explained and checked.</a:t>
+            </a:r>
+          </a:p>
+        </p:txBody>
+      </p:sp>
+    </p:spTree>
+  </p:cSld>
+  <p:clrMapOvr>
+    <a:masterClrMapping/>
+  </p:clrMapOvr>
+</p:sld>
+</file>
+
+<file path=ppt/slides/slide11.xml><?xml version="1.0" encoding="utf-8"?>
+<p:sld xmlns:a="http://schemas.openxmlformats.org/drawingml/2006/main" xmlns:p="http://schemas.openxmlformats.org/presentationml/2006/main" xmlns:r="http://schemas.openxmlformats.org/officeDocument/2006/relationships">
+  <p:cSld>
+    <p:bg>
+      <p:bgPr>
+        <a:solidFill>
+          <a:srgbClr val="FFFFFF"/>
+        </a:solidFill>
+        <a:effectLst/>
+      </p:bgPr>
+    </p:bg>
+    <p:spTree>
+      <p:nvGrpSpPr>
+        <p:cNvPr id="1" name=""/>
+        <p:cNvGrpSpPr/>
+        <p:nvPr/>
+      </p:nvGrpSpPr>
+      <p:grpSpPr/>
+      <p:sp>
+        <p:nvSpPr>
+          <p:cNvPr id="2" name="Rectangle 1"/>
+          <p:cNvSpPr/>
+          <p:nvPr/>
+        </p:nvSpPr>
+        <p:spPr>
+          <a:xfrm>
+            <a:off x="0" y="0"/>
+            <a:ext cx="12191695" cy="128016"/>
+          </a:xfrm>
+          <a:prstGeom prst="rect">
+            <a:avLst/>
+          </a:prstGeom>
+          <a:solidFill>
+            <a:srgbClr val="0E7C74"/>
+          </a:solidFill>
+          <a:ln>
+            <a:noFill/>
+          </a:ln>
+        </p:spPr>
+        <p:style>
+          <a:lnRef idx="1">
+            <a:schemeClr val="accent1"/>
+          </a:lnRef>
+          <a:fillRef idx="3">
+            <a:schemeClr val="accent1"/>
+          </a:fillRef>
+          <a:effectRef idx="2">
+            <a:schemeClr val="accent1"/>
+          </a:effectRef>
+          <a:fontRef idx="minor">
+            <a:schemeClr val="lt1"/>
+          </a:fontRef>
+        </p:style>
+        <p:txBody>
+          <a:bodyPr rtlCol="0" anchor="ctr"/>
+          <a:lstStyle/>
+          <a:p>
+            <a:pPr algn="ctr"/>
+          </a:p>
+        </p:txBody>
+      </p:sp>
+      <p:sp>
+        <p:nvSpPr>
+          <p:cNvPr id="3" name="TextBox 2"/>
+          <p:cNvSpPr txBox="1"/>
+          <p:nvPr/>
+        </p:nvSpPr>
+        <p:spPr>
+          <a:xfrm>
+            <a:off x="640080" y="384048"/>
+            <a:ext cx="11155680" cy="1280160"/>
+          </a:xfrm>
+          <a:prstGeom prst="rect">
+            <a:avLst/>
+          </a:prstGeom>
+          <a:noFill/>
+        </p:spPr>
+        <p:txBody>
+          <a:bodyPr wrap="square">
+            <a:spAutoFit/>
+          </a:bodyPr>
+          <a:lstStyle/>
+          <a:p>
+            <a:pPr>
+              <a:spcAft>
+                <a:spcPts val="500"/>
+              </a:spcAft>
+            </a:pPr>
+            <a:r>
+              <a:rPr sz="1250" b="1">
+                <a:solidFill>
+                  <a:srgbClr val="0E7C74"/>
+                </a:solidFill>
+                <a:latin typeface="Segoe UI"/>
+              </a:rPr>
+              <a:t>WORKED EXAMPLE</a:t>
+            </a:r>
+          </a:p>
+          <a:p>
+            <a:pPr>
+              <a:spcAft>
+                <a:spcPts val="0"/>
+              </a:spcAft>
+            </a:pPr>
+            <a:r>
+              <a:rPr sz="2700" b="1">
+                <a:solidFill>
+                  <a:srgbClr val="1A1F27"/>
+                </a:solidFill>
+                <a:latin typeface="Segoe UI"/>
+              </a:rPr>
+              <a:t>Golden data — what a coach certifies for one call</a:t>
+            </a:r>
+          </a:p>
+        </p:txBody>
+      </p:sp>
+      <p:graphicFrame>
+        <p:nvGraphicFramePr>
+          <p:cNvPr id="4" name="Table 3"/>
+          <p:cNvGraphicFramePr>
+            <a:graphicFrameLocks noGrp="1"/>
+          </p:cNvGraphicFramePr>
+          <p:nvPr/>
+        </p:nvGraphicFramePr>
+        <p:xfrm>
+          <a:off x="640080" y="1783080"/>
+          <a:ext cx="10927080" cy="3520440"/>
+        </p:xfrm>
+        <a:graphic>
+          <a:graphicData uri="http://schemas.openxmlformats.org/drawingml/2006/table">
+            <a:tbl>
+              <a:tblPr firstRow="1">
+                <a:tableStyleId>{5C22544A-7EE6-4342-B048-85BDC9FD1C3A}</a:tableStyleId>
+              </a:tblPr>
+              <a:tblGrid>
+                <a:gridCol w="4297680"/>
+                <a:gridCol w="6629400"/>
+              </a:tblGrid>
+              <a:tr h="502920">
+                <a:tc>
+                  <a:txBody>
+                    <a:bodyPr wrap="square"/>
+                    <a:lstStyle/>
+                    <a:p>
+                      <a:r>
+                        <a:rPr sz="1100" b="1">
+                          <a:solidFill>
+                            <a:srgbClr val="FFFFFF"/>
+                          </a:solidFill>
+                          <a:latin typeface="Segoe UI"/>
+                        </a:rPr>
+                        <a:t>Field</a:t>
+                      </a:r>
+                    </a:p>
+                  </a:txBody>
+                  <a:tcPr anchor="ctr" marL="82296" marR="54864" marT="18288" marB="18288">
+                    <a:solidFill>
+                      <a:srgbClr val="0E7C74"/>
+                    </a:solidFill>
+                  </a:tcPr>
+                </a:tc>
+                <a:tc>
+                  <a:txBody>
+                    <a:bodyPr wrap="square"/>
+                    <a:lstStyle/>
+                    <a:p>
+                      <a:r>
+                        <a:rPr sz="1100" b="1">
+                          <a:solidFill>
+                            <a:srgbClr val="FFFFFF"/>
+                          </a:solidFill>
+                          <a:latin typeface="Segoe UI"/>
+                        </a:rPr>
+                        <a:t>Certified answer</a:t>
+                      </a:r>
+                    </a:p>
+                  </a:txBody>
+                  <a:tcPr anchor="ctr" marL="82296" marR="54864" marT="18288" marB="18288">
+                    <a:solidFill>
+                      <a:srgbClr val="0E7C74"/>
+                    </a:solidFill>
+                  </a:tcPr>
+                </a:tc>
+              </a:tr>
+              <a:tr h="502920">
+                <a:tc>
+                  <a:txBody>
+                    <a:bodyPr wrap="square"/>
+                    <a:lstStyle/>
+                    <a:p>
+                      <a:r>
+                        <a:rPr sz="1350" b="1">
+                          <a:solidFill>
+                            <a:srgbClr val="1A1F27"/>
+                          </a:solidFill>
+                          <a:latin typeface="Segoe UI"/>
+                        </a:rPr>
+                        <a:t>new_line_opportunity_exists</a:t>
+                      </a:r>
+                    </a:p>
+                  </a:txBody>
+                  <a:tcPr anchor="ctr" marL="82296" marR="54864" marT="18288" marB="18288">
+                    <a:solidFill>
+                      <a:srgbClr val="FFFFFF"/>
+                    </a:solidFill>
+                  </a:tcPr>
+                </a:tc>
+                <a:tc>
+                  <a:txBody>
+                    <a:bodyPr wrap="square"/>
+                    <a:lstStyle/>
+                    <a:p>
+                      <a:r>
+                        <a:rPr sz="1350" b="0">
+                          <a:solidFill>
+                            <a:srgbClr val="535C6A"/>
+                          </a:solidFill>
+                          <a:latin typeface="Segoe UI"/>
+                        </a:rPr>
+                        <a:t>true</a:t>
+                      </a:r>
+                    </a:p>
+                  </a:txBody>
+                  <a:tcPr anchor="ctr" marL="82296" marR="54864" marT="18288" marB="18288">
+                    <a:solidFill>
+                      <a:srgbClr val="FFFFFF"/>
+                    </a:solidFill>
+                  </a:tcPr>
+                </a:tc>
+              </a:tr>
+              <a:tr h="502920">
+                <a:tc>
+                  <a:txBody>
+                    <a:bodyPr wrap="square"/>
+                    <a:lstStyle/>
+                    <a:p>
+                      <a:r>
+                        <a:rPr sz="1350" b="1">
+                          <a:solidFill>
+                            <a:srgbClr val="1A1F27"/>
+                          </a:solidFill>
+                          <a:latin typeface="Segoe UI"/>
+                        </a:rPr>
+                        <a:t>pitched_new_line</a:t>
+                      </a:r>
+                    </a:p>
+                  </a:txBody>
+                  <a:tcPr anchor="ctr" marL="82296" marR="54864" marT="18288" marB="18288">
+                    <a:solidFill>
+                      <a:srgbClr val="F7F9F8"/>
+                    </a:solidFill>
+                  </a:tcPr>
+                </a:tc>
+                <a:tc>
+                  <a:txBody>
+                    <a:bodyPr wrap="square"/>
+                    <a:lstStyle/>
+                    <a:p>
+                      <a:r>
+                        <a:rPr sz="1350" b="0">
+                          <a:solidFill>
+                            <a:srgbClr val="535C6A"/>
+                          </a:solidFill>
+                          <a:latin typeface="Segoe UI"/>
+                        </a:rPr>
+                        <a:t>false</a:t>
+                      </a:r>
+                    </a:p>
+                  </a:txBody>
+                  <a:tcPr anchor="ctr" marL="82296" marR="54864" marT="18288" marB="18288">
+                    <a:solidFill>
+                      <a:srgbClr val="F7F9F8"/>
+                    </a:solidFill>
+                  </a:tcPr>
+                </a:tc>
+              </a:tr>
+              <a:tr h="502920">
+                <a:tc>
+                  <a:txBody>
+                    <a:bodyPr wrap="square"/>
+                    <a:lstStyle/>
+                    <a:p>
+                      <a:r>
+                        <a:rPr sz="1350" b="1">
+                          <a:solidFill>
+                            <a:srgbClr val="1A1F27"/>
+                          </a:solidFill>
+                          <a:latin typeface="Segoe UI"/>
+                        </a:rPr>
+                        <a:t>escalation</a:t>
+                      </a:r>
+                    </a:p>
+                  </a:txBody>
+                  <a:tcPr anchor="ctr" marL="82296" marR="54864" marT="18288" marB="18288">
+                    <a:solidFill>
+                      <a:srgbClr val="FFFFFF"/>
+                    </a:solidFill>
+                  </a:tcPr>
+                </a:tc>
+                <a:tc>
+                  <a:txBody>
+                    <a:bodyPr wrap="square"/>
+                    <a:lstStyle/>
+                    <a:p>
+                      <a:r>
+                        <a:rPr sz="1350" b="0">
+                          <a:solidFill>
+                            <a:srgbClr val="535C6A"/>
+                          </a:solidFill>
+                          <a:latin typeface="Segoe UI"/>
+                        </a:rPr>
+                        <a:t>none</a:t>
+                      </a:r>
+                    </a:p>
+                  </a:txBody>
+                  <a:tcPr anchor="ctr" marL="82296" marR="54864" marT="18288" marB="18288">
+                    <a:solidFill>
+                      <a:srgbClr val="FFFFFF"/>
+                    </a:solidFill>
+                  </a:tcPr>
+                </a:tc>
+              </a:tr>
+              <a:tr h="502920">
+                <a:tc>
+                  <a:txBody>
+                    <a:bodyPr wrap="square"/>
+                    <a:lstStyle/>
+                    <a:p>
+                      <a:r>
+                        <a:rPr sz="1350" b="1">
+                          <a:solidFill>
+                            <a:srgbClr val="1A1F27"/>
+                          </a:solidFill>
+                          <a:latin typeface="Segoe UI"/>
+                        </a:rPr>
+                        <a:t>customer_experience</a:t>
+                      </a:r>
+                    </a:p>
+                  </a:txBody>
+                  <a:tcPr anchor="ctr" marL="82296" marR="54864" marT="18288" marB="18288">
+                    <a:solidFill>
+                      <a:srgbClr val="F7F9F8"/>
+                    </a:solidFill>
+                  </a:tcPr>
+                </a:tc>
+                <a:tc>
+                  <a:txBody>
+                    <a:bodyPr wrap="square"/>
+                    <a:lstStyle/>
+                    <a:p>
+                      <a:r>
+                        <a:rPr sz="1350" b="0">
+                          <a:solidFill>
+                            <a:srgbClr val="535C6A"/>
+                          </a:solidFill>
+                          <a:latin typeface="Segoe UI"/>
+                        </a:rPr>
+                        <a:t>Medium</a:t>
+                      </a:r>
+                    </a:p>
+                  </a:txBody>
+                  <a:tcPr anchor="ctr" marL="82296" marR="54864" marT="18288" marB="18288">
+                    <a:solidFill>
+                      <a:srgbClr val="F7F9F8"/>
+                    </a:solidFill>
+                  </a:tcPr>
+                </a:tc>
+              </a:tr>
+              <a:tr h="502920">
+                <a:tc>
+                  <a:txBody>
+                    <a:bodyPr wrap="square"/>
+                    <a:lstStyle/>
+                    <a:p>
+                      <a:r>
+                        <a:rPr sz="1350" b="1">
+                          <a:solidFill>
+                            <a:srgbClr val="1A1F27"/>
+                          </a:solidFill>
+                          <a:latin typeface="Segoe UI"/>
+                        </a:rPr>
+                        <a:t>Evidence</a:t>
+                      </a:r>
+                    </a:p>
+                  </a:txBody>
+                  <a:tcPr anchor="ctr" marL="82296" marR="54864" marT="18288" marB="18288">
+                    <a:solidFill>
+                      <a:srgbClr val="FFFFFF"/>
+                    </a:solidFill>
+                  </a:tcPr>
+                </a:tc>
+                <a:tc>
+                  <a:txBody>
+                    <a:bodyPr wrap="square"/>
+                    <a:lstStyle/>
+                    <a:p>
+                      <a:r>
+                        <a:rPr sz="1350" b="0">
+                          <a:solidFill>
+                            <a:srgbClr val="535C6A"/>
+                          </a:solidFill>
+                          <a:latin typeface="Segoe UI"/>
+                        </a:rPr>
+                        <a:t>lines 12–14 of the call</a:t>
+                      </a:r>
+                    </a:p>
+                  </a:txBody>
+                  <a:tcPr anchor="ctr" marL="82296" marR="54864" marT="18288" marB="18288">
+                    <a:solidFill>
+                      <a:srgbClr val="FFFFFF"/>
+                    </a:solidFill>
+                  </a:tcPr>
+                </a:tc>
+              </a:tr>
+              <a:tr h="502920">
+                <a:tc>
+                  <a:txBody>
+                    <a:bodyPr wrap="square"/>
+                    <a:lstStyle/>
+                    <a:p>
+                      <a:r>
+                        <a:rPr sz="1350" b="1">
+                          <a:solidFill>
+                            <a:srgbClr val="1A1F27"/>
+                          </a:solidFill>
+                          <a:latin typeface="Segoe UI"/>
+                        </a:rPr>
+                        <a:t>Certified by</a:t>
+                      </a:r>
+                    </a:p>
+                  </a:txBody>
+                  <a:tcPr anchor="ctr" marL="82296" marR="54864" marT="18288" marB="18288">
+                    <a:solidFill>
+                      <a:srgbClr val="F7F9F8"/>
+                    </a:solidFill>
+                  </a:tcPr>
+                </a:tc>
+                <a:tc>
+                  <a:txBody>
+                    <a:bodyPr wrap="square"/>
+                    <a:lstStyle/>
+                    <a:p>
+                      <a:r>
+                        <a:rPr sz="1350" b="0">
+                          <a:solidFill>
+                            <a:srgbClr val="535C6A"/>
+                          </a:solidFill>
+                          <a:latin typeface="Segoe UI"/>
+                        </a:rPr>
+                        <a:t>2 coaches · 8 Sep</a:t>
+                      </a:r>
+                    </a:p>
+                  </a:txBody>
+                  <a:tcPr anchor="ctr" marL="82296" marR="54864" marT="18288" marB="18288">
+                    <a:solidFill>
+                      <a:srgbClr val="F7F9F8"/>
+                    </a:solidFill>
+                  </a:tcPr>
+                </a:tc>
+              </a:tr>
+            </a:tbl>
+          </a:graphicData>
+        </a:graphic>
+      </p:graphicFrame>
+      <p:sp>
+        <p:nvSpPr>
+          <p:cNvPr id="5" name="Rectangle 4"/>
+          <p:cNvSpPr/>
+          <p:nvPr/>
+        </p:nvSpPr>
+        <p:spPr>
+          <a:xfrm>
+            <a:off x="685800" y="5760720"/>
+            <a:ext cx="10881360" cy="822960"/>
+          </a:xfrm>
+          <a:prstGeom prst="rect">
+            <a:avLst/>
+          </a:prstGeom>
+          <a:solidFill>
+            <a:srgbClr val="F2F5F4"/>
+          </a:solidFill>
+          <a:ln>
+            <a:noFill/>
+          </a:ln>
+        </p:spPr>
+        <p:style>
+          <a:lnRef idx="1">
+            <a:schemeClr val="accent1"/>
+          </a:lnRef>
+          <a:fillRef idx="3">
+            <a:schemeClr val="accent1"/>
+          </a:fillRef>
+          <a:effectRef idx="2">
+            <a:schemeClr val="accent1"/>
+          </a:effectRef>
+          <a:fontRef idx="minor">
+            <a:schemeClr val="lt1"/>
+          </a:fontRef>
+        </p:style>
+        <p:txBody>
+          <a:bodyPr rtlCol="0" anchor="ctr" wrap="square" lIns="228600" rIns="228600"/>
+          <a:lstStyle/>
+          <a:p>
+            <a:pPr algn="ctr">
+              <a:spcAft>
+                <a:spcPts val="0"/>
+              </a:spcAft>
+            </a:pPr>
+            <a:r>
+              <a:rPr sz="1600" b="1">
+                <a:solidFill>
+                  <a:srgbClr val="0E7C74"/>
+                </a:solidFill>
+                <a:latin typeface="Segoe UI"/>
+              </a:rPr>
+              <a:t>A transcript becomes “golden” only when 2 or more coaches agree on its answers — not because we picked it. Disagreement means the definition needs fixing first.</a:t>
+            </a:r>
+          </a:p>
+        </p:txBody>
+      </p:sp>
+    </p:spTree>
+  </p:cSld>
+  <p:clrMapOvr>
+    <a:masterClrMapping/>
+  </p:clrMapOvr>
+</p:sld>
+</file>
+
 <file path=ppt/slides/slide2.xml><?xml version="1.0" encoding="utf-8"?>
 <p:sld xmlns:a="http://schemas.openxmlformats.org/drawingml/2006/main" xmlns:p="http://schemas.openxmlformats.org/presentationml/2006/main" xmlns:r="http://schemas.openxmlformats.org/officeDocument/2006/relationships">
   <p:cSld>

</xml_diff>

<commit_message>
Relabel example transcripts as MOCK CALL TRANSCRIPT for clarity
</commit_message>
<xml_diff>
--- a/usecases/ai_pipeline 2/docs/APIX_Metrics_Discussion.pptx
+++ b/usecases/ai_pipeline 2/docs/APIX_Metrics_Discussion.pptx
@@ -3987,7 +3987,7 @@
                 </a:solidFill>
                 <a:latin typeface="Segoe UI"/>
               </a:rPr>
-              <a:t>TRANSCRIPT (excerpt)</a:t>
+              <a:t>MOCK CALL TRANSCRIPT — APIX example (illustrative)</a:t>
             </a:r>
           </a:p>
           <a:p>
@@ -4575,7 +4575,7 @@
                 </a:solidFill>
                 <a:latin typeface="Segoe UI"/>
               </a:rPr>
-              <a:t>TRANSCRIPT (excerpt)</a:t>
+              <a:t>MOCK CALL TRANSCRIPT — APIX example (illustrative)</a:t>
             </a:r>
           </a:p>
           <a:p>

</xml_diff>

<commit_message>
Restyle decks: corporate navy palette, flattened squared blocks (less templated)
</commit_message>
<xml_diff>
--- a/usecases/ai_pipeline 2/docs/APIX_Metrics_Discussion.pptx
+++ b/usecases/ai_pipeline 2/docs/APIX_Metrics_Discussion.pptx
@@ -3118,7 +3118,7 @@
             <a:avLst/>
           </a:prstGeom>
           <a:solidFill>
-            <a:srgbClr val="0E7C74"/>
+            <a:srgbClr val="16324F"/>
           </a:solidFill>
           <a:ln>
             <a:noFill/>
@@ -3177,7 +3177,7 @@
             <a:r>
               <a:rPr sz="1350" b="1">
                 <a:solidFill>
-                  <a:srgbClr val="0E7C74"/>
+                  <a:srgbClr val="16324F"/>
                 </a:solidFill>
                 <a:latin typeface="Segoe UI"/>
               </a:rPr>
@@ -3193,7 +3193,7 @@
             <a:r>
               <a:rPr sz="3400" b="1">
                 <a:solidFill>
-                  <a:srgbClr val="1A1F27"/>
+                  <a:srgbClr val="1C2733"/>
                 </a:solidFill>
                 <a:latin typeface="Segoe UI"/>
               </a:rPr>
@@ -3209,7 +3209,7 @@
             <a:r>
               <a:rPr sz="3400" b="1">
                 <a:solidFill>
-                  <a:srgbClr val="1A1F27"/>
+                  <a:srgbClr val="1C2733"/>
                 </a:solidFill>
                 <a:latin typeface="Segoe UI"/>
               </a:rPr>
@@ -3225,7 +3225,7 @@
             <a:r>
               <a:rPr sz="1650" b="0">
                 <a:solidFill>
-                  <a:srgbClr val="535C6A"/>
+                  <a:srgbClr val="566573"/>
                 </a:solidFill>
                 <a:latin typeface="Segoe UI"/>
               </a:rPr>
@@ -3264,7 +3264,7 @@
             <a:r>
               <a:rPr sz="1250" b="0">
                 <a:solidFill>
-                  <a:srgbClr val="8A93A1"/>
+                  <a:srgbClr val="93A0AD"/>
                 </a:solidFill>
                 <a:latin typeface="Segoe UI"/>
               </a:rPr>
@@ -3314,7 +3314,7 @@
             <a:avLst/>
           </a:prstGeom>
           <a:solidFill>
-            <a:srgbClr val="0E7C74"/>
+            <a:srgbClr val="16324F"/>
           </a:solidFill>
           <a:ln>
             <a:noFill/>
@@ -3373,7 +3373,7 @@
             <a:r>
               <a:rPr sz="1200" b="1">
                 <a:solidFill>
-                  <a:srgbClr val="0E7C74"/>
+                  <a:srgbClr val="16324F"/>
                 </a:solidFill>
                 <a:latin typeface="Segoe UI"/>
               </a:rPr>
@@ -3389,7 +3389,7 @@
             <a:r>
               <a:rPr sz="2400" b="1">
                 <a:solidFill>
-                  <a:srgbClr val="1A1F27"/>
+                  <a:srgbClr val="1C2733"/>
                 </a:solidFill>
                 <a:latin typeface="Segoe UI"/>
               </a:rPr>
@@ -3400,7 +3400,7 @@
       </p:sp>
       <p:sp>
         <p:nvSpPr>
-          <p:cNvPr id="4" name="Rounded Rectangle 3"/>
+          <p:cNvPr id="4" name="Rectangle 3"/>
           <p:cNvSpPr/>
           <p:nvPr/>
         </p:nvSpPr>
@@ -3409,15 +3409,15 @@
             <a:off x="640080" y="1691640"/>
             <a:ext cx="5486400" cy="1828800"/>
           </a:xfrm>
-          <a:prstGeom prst="roundRect">
+          <a:prstGeom prst="rect">
             <a:avLst/>
           </a:prstGeom>
           <a:solidFill>
-            <a:srgbClr val="E1F0EE"/>
+            <a:srgbClr val="EAEEF2"/>
           </a:solidFill>
           <a:ln w="9525">
             <a:solidFill>
-              <a:srgbClr val="D9DFE5"/>
+              <a:srgbClr val="D5DBE1"/>
             </a:solidFill>
           </a:ln>
           <a:effectLst/>
@@ -3448,7 +3448,7 @@
             <a:r>
               <a:rPr sz="1250" b="1">
                 <a:solidFill>
-                  <a:srgbClr val="0E7C74"/>
+                  <a:srgbClr val="16324F"/>
                 </a:solidFill>
                 <a:latin typeface="Segoe UI"/>
               </a:rPr>
@@ -3464,7 +3464,7 @@
             <a:r>
               <a:rPr sz="1150" b="0">
                 <a:solidFill>
-                  <a:srgbClr val="535C6A"/>
+                  <a:srgbClr val="566573"/>
                 </a:solidFill>
                 <a:latin typeface="Segoe UI"/>
               </a:rPr>
@@ -3480,7 +3480,7 @@
             <a:r>
               <a:rPr sz="1150" b="0">
                 <a:solidFill>
-                  <a:srgbClr val="535C6A"/>
+                  <a:srgbClr val="566573"/>
                 </a:solidFill>
                 <a:latin typeface="Segoe UI"/>
               </a:rPr>
@@ -3496,7 +3496,7 @@
             <a:r>
               <a:rPr sz="1150" b="0">
                 <a:solidFill>
-                  <a:srgbClr val="535C6A"/>
+                  <a:srgbClr val="566573"/>
                 </a:solidFill>
                 <a:latin typeface="Segoe UI"/>
               </a:rPr>
@@ -3512,7 +3512,7 @@
             <a:r>
               <a:rPr sz="1150" b="0">
                 <a:solidFill>
-                  <a:srgbClr val="535C6A"/>
+                  <a:srgbClr val="566573"/>
                 </a:solidFill>
                 <a:latin typeface="Segoe UI"/>
               </a:rPr>
@@ -3528,7 +3528,7 @@
             <a:r>
               <a:rPr sz="1150" b="0">
                 <a:solidFill>
-                  <a:srgbClr val="535C6A"/>
+                  <a:srgbClr val="566573"/>
                 </a:solidFill>
                 <a:latin typeface="Segoe UI"/>
               </a:rPr>
@@ -3539,7 +3539,7 @@
       </p:sp>
       <p:sp>
         <p:nvSpPr>
-          <p:cNvPr id="5" name="Rounded Rectangle 4"/>
+          <p:cNvPr id="5" name="Rectangle 4"/>
           <p:cNvSpPr/>
           <p:nvPr/>
         </p:nvSpPr>
@@ -3548,15 +3548,15 @@
             <a:off x="6355080" y="1691640"/>
             <a:ext cx="5212080" cy="1828800"/>
           </a:xfrm>
-          <a:prstGeom prst="roundRect">
+          <a:prstGeom prst="rect">
             <a:avLst/>
           </a:prstGeom>
           <a:solidFill>
-            <a:srgbClr val="E1F0EE"/>
+            <a:srgbClr val="EAEEF2"/>
           </a:solidFill>
           <a:ln w="9525">
             <a:solidFill>
-              <a:srgbClr val="D9DFE5"/>
+              <a:srgbClr val="D5DBE1"/>
             </a:solidFill>
           </a:ln>
           <a:effectLst/>
@@ -3587,7 +3587,7 @@
             <a:r>
               <a:rPr sz="1250" b="1">
                 <a:solidFill>
-                  <a:srgbClr val="0E7C74"/>
+                  <a:srgbClr val="16324F"/>
                 </a:solidFill>
                 <a:latin typeface="Segoe UI"/>
               </a:rPr>
@@ -3603,7 +3603,7 @@
             <a:r>
               <a:rPr sz="1150" b="0">
                 <a:solidFill>
-                  <a:srgbClr val="535C6A"/>
+                  <a:srgbClr val="566573"/>
                 </a:solidFill>
                 <a:latin typeface="Segoe UI"/>
               </a:rPr>
@@ -3619,7 +3619,7 @@
             <a:r>
               <a:rPr sz="1150" b="0">
                 <a:solidFill>
-                  <a:srgbClr val="535C6A"/>
+                  <a:srgbClr val="566573"/>
                 </a:solidFill>
                 <a:latin typeface="Segoe UI"/>
               </a:rPr>
@@ -3635,7 +3635,7 @@
             <a:r>
               <a:rPr sz="1150" b="0">
                 <a:solidFill>
-                  <a:srgbClr val="535C6A"/>
+                  <a:srgbClr val="566573"/>
                 </a:solidFill>
                 <a:latin typeface="Segoe UI"/>
               </a:rPr>
@@ -3651,7 +3651,7 @@
             <a:r>
               <a:rPr sz="1150" b="0">
                 <a:solidFill>
-                  <a:srgbClr val="535C6A"/>
+                  <a:srgbClr val="566573"/>
                 </a:solidFill>
                 <a:latin typeface="Segoe UI"/>
               </a:rPr>
@@ -3662,7 +3662,7 @@
       </p:sp>
       <p:sp>
         <p:nvSpPr>
-          <p:cNvPr id="6" name="Rounded Rectangle 5"/>
+          <p:cNvPr id="6" name="Rectangle 5"/>
           <p:cNvSpPr/>
           <p:nvPr/>
         </p:nvSpPr>
@@ -3671,11 +3671,11 @@
             <a:off x="640080" y="3794760"/>
             <a:ext cx="10927080" cy="868680"/>
           </a:xfrm>
-          <a:prstGeom prst="roundRect">
+          <a:prstGeom prst="rect">
             <a:avLst/>
           </a:prstGeom>
           <a:solidFill>
-            <a:srgbClr val="E1F0EE"/>
+            <a:srgbClr val="EAEEF2"/>
           </a:solidFill>
           <a:ln>
             <a:noFill/>
@@ -3708,7 +3708,7 @@
             <a:r>
               <a:rPr sz="1400" b="1">
                 <a:solidFill>
-                  <a:srgbClr val="0A5B55"/>
+                  <a:srgbClr val="122A42"/>
                 </a:solidFill>
                 <a:latin typeface="Segoe UI"/>
               </a:rPr>
@@ -3719,7 +3719,7 @@
       </p:sp>
       <p:sp>
         <p:nvSpPr>
-          <p:cNvPr id="7" name="Rounded Rectangle 6"/>
+          <p:cNvPr id="7" name="Rectangle 6"/>
           <p:cNvSpPr/>
           <p:nvPr/>
         </p:nvSpPr>
@@ -3728,15 +3728,15 @@
             <a:off x="640080" y="4892040"/>
             <a:ext cx="10927080" cy="1234440"/>
           </a:xfrm>
-          <a:prstGeom prst="roundRect">
+          <a:prstGeom prst="rect">
             <a:avLst/>
           </a:prstGeom>
           <a:solidFill>
-            <a:srgbClr val="E1F0EE"/>
+            <a:srgbClr val="EAEEF2"/>
           </a:solidFill>
           <a:ln w="9525">
             <a:solidFill>
-              <a:srgbClr val="D9DFE5"/>
+              <a:srgbClr val="D5DBE1"/>
             </a:solidFill>
           </a:ln>
           <a:effectLst/>
@@ -3767,7 +3767,7 @@
             <a:r>
               <a:rPr sz="1250" b="1">
                 <a:solidFill>
-                  <a:srgbClr val="0E7C74"/>
+                  <a:srgbClr val="16324F"/>
                 </a:solidFill>
                 <a:latin typeface="Segoe UI"/>
               </a:rPr>
@@ -3783,7 +3783,7 @@
             <a:r>
               <a:rPr sz="1100" b="0">
                 <a:solidFill>
-                  <a:srgbClr val="0A5B55"/>
+                  <a:srgbClr val="122A42"/>
                 </a:solidFill>
                 <a:latin typeface="Segoe UI"/>
               </a:rPr>
@@ -3799,7 +3799,7 @@
             <a:r>
               <a:rPr sz="1100" b="0">
                 <a:solidFill>
-                  <a:srgbClr val="535C6A"/>
+                  <a:srgbClr val="566573"/>
                 </a:solidFill>
                 <a:latin typeface="Segoe UI"/>
               </a:rPr>
@@ -3849,7 +3849,7 @@
             <a:avLst/>
           </a:prstGeom>
           <a:solidFill>
-            <a:srgbClr val="0E7C74"/>
+            <a:srgbClr val="16324F"/>
           </a:solidFill>
           <a:ln>
             <a:noFill/>
@@ -3908,7 +3908,7 @@
             <a:r>
               <a:rPr sz="1200" b="1">
                 <a:solidFill>
-                  <a:srgbClr val="0E7C74"/>
+                  <a:srgbClr val="16324F"/>
                 </a:solidFill>
                 <a:latin typeface="Segoe UI"/>
               </a:rPr>
@@ -3924,7 +3924,7 @@
             <a:r>
               <a:rPr sz="2400" b="1">
                 <a:solidFill>
-                  <a:srgbClr val="1A1F27"/>
+                  <a:srgbClr val="1C2733"/>
                 </a:solidFill>
                 <a:latin typeface="Segoe UI"/>
               </a:rPr>
@@ -3935,7 +3935,7 @@
       </p:sp>
       <p:sp>
         <p:nvSpPr>
-          <p:cNvPr id="4" name="Rounded Rectangle 3"/>
+          <p:cNvPr id="4" name="Rectangle 3"/>
           <p:cNvSpPr/>
           <p:nvPr/>
         </p:nvSpPr>
@@ -3944,15 +3944,15 @@
             <a:off x="640080" y="1691640"/>
             <a:ext cx="6035040" cy="3977639"/>
           </a:xfrm>
-          <a:prstGeom prst="roundRect">
+          <a:prstGeom prst="rect">
             <a:avLst/>
           </a:prstGeom>
           <a:solidFill>
-            <a:srgbClr val="F3F1EA"/>
+            <a:srgbClr val="F3F1EC"/>
           </a:solidFill>
           <a:ln w="9525">
             <a:solidFill>
-              <a:srgbClr val="D9DFE5"/>
+              <a:srgbClr val="D5DBE1"/>
             </a:solidFill>
           </a:ln>
           <a:effectLst/>
@@ -3983,7 +3983,7 @@
             <a:r>
               <a:rPr sz="1250" b="1">
                 <a:solidFill>
-                  <a:srgbClr val="0A5B55"/>
+                  <a:srgbClr val="122A42"/>
                 </a:solidFill>
                 <a:latin typeface="Segoe UI"/>
               </a:rPr>
@@ -3999,7 +3999,7 @@
             <a:r>
               <a:rPr sz="1050" b="0">
                 <a:solidFill>
-                  <a:srgbClr val="1A1F27"/>
+                  <a:srgbClr val="1C2733"/>
                 </a:solidFill>
                 <a:latin typeface="Consolas"/>
               </a:rPr>
@@ -4015,7 +4015,7 @@
             <a:r>
               <a:rPr sz="1050" b="0">
                 <a:solidFill>
-                  <a:srgbClr val="1A1F27"/>
+                  <a:srgbClr val="1C2733"/>
                 </a:solidFill>
                 <a:latin typeface="Consolas"/>
               </a:rPr>
@@ -4031,7 +4031,7 @@
             <a:r>
               <a:rPr sz="1050" b="0">
                 <a:solidFill>
-                  <a:srgbClr val="1A1F27"/>
+                  <a:srgbClr val="1C2733"/>
                 </a:solidFill>
                 <a:latin typeface="Consolas"/>
               </a:rPr>
@@ -4047,7 +4047,7 @@
             <a:r>
               <a:rPr sz="1050" b="0">
                 <a:solidFill>
-                  <a:srgbClr val="1A1F27"/>
+                  <a:srgbClr val="1C2733"/>
                 </a:solidFill>
                 <a:latin typeface="Consolas"/>
               </a:rPr>
@@ -4063,7 +4063,7 @@
             <a:r>
               <a:rPr sz="1050" b="0">
                 <a:solidFill>
-                  <a:srgbClr val="1A1F27"/>
+                  <a:srgbClr val="1C2733"/>
                 </a:solidFill>
                 <a:latin typeface="Consolas"/>
               </a:rPr>
@@ -4079,7 +4079,7 @@
             <a:r>
               <a:rPr sz="1050" b="0">
                 <a:solidFill>
-                  <a:srgbClr val="1A1F27"/>
+                  <a:srgbClr val="1C2733"/>
                 </a:solidFill>
                 <a:latin typeface="Consolas"/>
               </a:rPr>
@@ -4095,7 +4095,7 @@
             <a:r>
               <a:rPr sz="1050" b="0">
                 <a:solidFill>
-                  <a:srgbClr val="1A1F27"/>
+                  <a:srgbClr val="1C2733"/>
                 </a:solidFill>
                 <a:latin typeface="Consolas"/>
               </a:rPr>
@@ -4111,7 +4111,7 @@
             <a:r>
               <a:rPr sz="1050" b="0">
                 <a:solidFill>
-                  <a:srgbClr val="1A1F27"/>
+                  <a:srgbClr val="1C2733"/>
                 </a:solidFill>
                 <a:latin typeface="Consolas"/>
               </a:rPr>
@@ -4122,7 +4122,7 @@
       </p:sp>
       <p:sp>
         <p:nvSpPr>
-          <p:cNvPr id="5" name="Rounded Rectangle 4"/>
+          <p:cNvPr id="5" name="Rectangle 4"/>
           <p:cNvSpPr/>
           <p:nvPr/>
         </p:nvSpPr>
@@ -4131,15 +4131,15 @@
             <a:off x="6903720" y="1691640"/>
             <a:ext cx="4663440" cy="3977639"/>
           </a:xfrm>
-          <a:prstGeom prst="roundRect">
+          <a:prstGeom prst="rect">
             <a:avLst/>
           </a:prstGeom>
           <a:solidFill>
-            <a:srgbClr val="E4F3EB"/>
+            <a:srgbClr val="E8F0EA"/>
           </a:solidFill>
           <a:ln w="9525">
             <a:solidFill>
-              <a:srgbClr val="D9DFE5"/>
+              <a:srgbClr val="D5DBE1"/>
             </a:solidFill>
           </a:ln>
           <a:effectLst/>
@@ -4170,7 +4170,7 @@
             <a:r>
               <a:rPr sz="1250" b="1">
                 <a:solidFill>
-                  <a:srgbClr val="2E8B5E"/>
+                  <a:srgbClr val="2F6E4E"/>
                 </a:solidFill>
                 <a:latin typeface="Segoe UI"/>
               </a:rPr>
@@ -4186,7 +4186,7 @@
             <a:r>
               <a:rPr sz="1050" b="0">
                 <a:solidFill>
-                  <a:srgbClr val="0A5B55"/>
+                  <a:srgbClr val="122A42"/>
                 </a:solidFill>
                 <a:latin typeface="Consolas"/>
               </a:rPr>
@@ -4202,7 +4202,7 @@
             <a:r>
               <a:rPr sz="1050" b="0">
                 <a:solidFill>
-                  <a:srgbClr val="0A5B55"/>
+                  <a:srgbClr val="122A42"/>
                 </a:solidFill>
                 <a:latin typeface="Consolas"/>
               </a:rPr>
@@ -4218,7 +4218,7 @@
             <a:r>
               <a:rPr sz="1050" b="0">
                 <a:solidFill>
-                  <a:srgbClr val="0A5B55"/>
+                  <a:srgbClr val="122A42"/>
                 </a:solidFill>
                 <a:latin typeface="Consolas"/>
               </a:rPr>
@@ -4234,7 +4234,7 @@
             <a:r>
               <a:rPr sz="1050" b="0">
                 <a:solidFill>
-                  <a:srgbClr val="0A5B55"/>
+                  <a:srgbClr val="122A42"/>
                 </a:solidFill>
                 <a:latin typeface="Consolas"/>
               </a:rPr>
@@ -4250,7 +4250,7 @@
             <a:r>
               <a:rPr sz="1050" b="0">
                 <a:solidFill>
-                  <a:srgbClr val="0A5B55"/>
+                  <a:srgbClr val="122A42"/>
                 </a:solidFill>
                 <a:latin typeface="Consolas"/>
               </a:rPr>
@@ -4266,7 +4266,7 @@
             <a:r>
               <a:rPr sz="1050" b="0">
                 <a:solidFill>
-                  <a:srgbClr val="0A5B55"/>
+                  <a:srgbClr val="122A42"/>
                 </a:solidFill>
                 <a:latin typeface="Consolas"/>
               </a:rPr>
@@ -4282,7 +4282,7 @@
             <a:r>
               <a:rPr sz="1050" b="0">
                 <a:solidFill>
-                  <a:srgbClr val="0A5B55"/>
+                  <a:srgbClr val="122A42"/>
                 </a:solidFill>
                 <a:latin typeface="Consolas"/>
               </a:rPr>
@@ -4298,7 +4298,7 @@
             <a:r>
               <a:rPr sz="1050" b="0">
                 <a:solidFill>
-                  <a:srgbClr val="0A5B55"/>
+                  <a:srgbClr val="122A42"/>
                 </a:solidFill>
                 <a:latin typeface="Consolas"/>
               </a:rPr>
@@ -4314,7 +4314,7 @@
             <a:r>
               <a:rPr sz="1050" b="0">
                 <a:solidFill>
-                  <a:srgbClr val="1A1F27"/>
+                  <a:srgbClr val="1C2733"/>
                 </a:solidFill>
                 <a:latin typeface="Segoe UI"/>
               </a:rPr>
@@ -4330,7 +4330,7 @@
             <a:r>
               <a:rPr sz="1050" b="0">
                 <a:solidFill>
-                  <a:srgbClr val="2E8B5E"/>
+                  <a:srgbClr val="2F6E4E"/>
                 </a:solidFill>
                 <a:latin typeface="Segoe UI"/>
               </a:rPr>
@@ -4341,7 +4341,7 @@
       </p:sp>
       <p:sp>
         <p:nvSpPr>
-          <p:cNvPr id="6" name="Rounded Rectangle 5"/>
+          <p:cNvPr id="6" name="Rectangle 5"/>
           <p:cNvSpPr/>
           <p:nvPr/>
         </p:nvSpPr>
@@ -4350,11 +4350,11 @@
             <a:off x="640080" y="5806440"/>
             <a:ext cx="10927080" cy="731520"/>
           </a:xfrm>
-          <a:prstGeom prst="roundRect">
+          <a:prstGeom prst="rect">
             <a:avLst/>
           </a:prstGeom>
           <a:solidFill>
-            <a:srgbClr val="E1F0EE"/>
+            <a:srgbClr val="EAEEF2"/>
           </a:solidFill>
           <a:ln>
             <a:noFill/>
@@ -4387,7 +4387,7 @@
             <a:r>
               <a:rPr sz="1350" b="1">
                 <a:solidFill>
-                  <a:srgbClr val="0A5B55"/>
+                  <a:srgbClr val="122A42"/>
                 </a:solidFill>
                 <a:latin typeface="Segoe UI"/>
               </a:rPr>
@@ -4437,7 +4437,7 @@
             <a:avLst/>
           </a:prstGeom>
           <a:solidFill>
-            <a:srgbClr val="0E7C74"/>
+            <a:srgbClr val="16324F"/>
           </a:solidFill>
           <a:ln>
             <a:noFill/>
@@ -4496,7 +4496,7 @@
             <a:r>
               <a:rPr sz="1200" b="1">
                 <a:solidFill>
-                  <a:srgbClr val="0E7C74"/>
+                  <a:srgbClr val="16324F"/>
                 </a:solidFill>
                 <a:latin typeface="Segoe UI"/>
               </a:rPr>
@@ -4512,7 +4512,7 @@
             <a:r>
               <a:rPr sz="2400" b="1">
                 <a:solidFill>
-                  <a:srgbClr val="1A1F27"/>
+                  <a:srgbClr val="1C2733"/>
                 </a:solidFill>
                 <a:latin typeface="Segoe UI"/>
               </a:rPr>
@@ -4523,7 +4523,7 @@
       </p:sp>
       <p:sp>
         <p:nvSpPr>
-          <p:cNvPr id="4" name="Rounded Rectangle 3"/>
+          <p:cNvPr id="4" name="Rectangle 3"/>
           <p:cNvSpPr/>
           <p:nvPr/>
         </p:nvSpPr>
@@ -4532,15 +4532,15 @@
             <a:off x="640080" y="1691640"/>
             <a:ext cx="6035040" cy="3977639"/>
           </a:xfrm>
-          <a:prstGeom prst="roundRect">
+          <a:prstGeom prst="rect">
             <a:avLst/>
           </a:prstGeom>
           <a:solidFill>
-            <a:srgbClr val="F3F1EA"/>
+            <a:srgbClr val="F3F1EC"/>
           </a:solidFill>
           <a:ln w="9525">
             <a:solidFill>
-              <a:srgbClr val="D9DFE5"/>
+              <a:srgbClr val="D5DBE1"/>
             </a:solidFill>
           </a:ln>
           <a:effectLst/>
@@ -4571,7 +4571,7 @@
             <a:r>
               <a:rPr sz="1250" b="1">
                 <a:solidFill>
-                  <a:srgbClr val="0A5B55"/>
+                  <a:srgbClr val="122A42"/>
                 </a:solidFill>
                 <a:latin typeface="Segoe UI"/>
               </a:rPr>
@@ -4587,7 +4587,7 @@
             <a:r>
               <a:rPr sz="1050" b="0">
                 <a:solidFill>
-                  <a:srgbClr val="1A1F27"/>
+                  <a:srgbClr val="1C2733"/>
                 </a:solidFill>
                 <a:latin typeface="Consolas"/>
               </a:rPr>
@@ -4603,7 +4603,7 @@
             <a:r>
               <a:rPr sz="1050" b="0">
                 <a:solidFill>
-                  <a:srgbClr val="1A1F27"/>
+                  <a:srgbClr val="1C2733"/>
                 </a:solidFill>
                 <a:latin typeface="Consolas"/>
               </a:rPr>
@@ -4619,7 +4619,7 @@
             <a:r>
               <a:rPr sz="1050" b="0">
                 <a:solidFill>
-                  <a:srgbClr val="1A1F27"/>
+                  <a:srgbClr val="1C2733"/>
                 </a:solidFill>
                 <a:latin typeface="Consolas"/>
               </a:rPr>
@@ -4635,7 +4635,7 @@
             <a:r>
               <a:rPr sz="1050" b="0">
                 <a:solidFill>
-                  <a:srgbClr val="1A1F27"/>
+                  <a:srgbClr val="1C2733"/>
                 </a:solidFill>
                 <a:latin typeface="Consolas"/>
               </a:rPr>
@@ -4651,7 +4651,7 @@
             <a:r>
               <a:rPr sz="1050" b="0">
                 <a:solidFill>
-                  <a:srgbClr val="1A1F27"/>
+                  <a:srgbClr val="1C2733"/>
                 </a:solidFill>
                 <a:latin typeface="Consolas"/>
               </a:rPr>
@@ -4667,7 +4667,7 @@
             <a:r>
               <a:rPr sz="1050" b="0">
                 <a:solidFill>
-                  <a:srgbClr val="1A1F27"/>
+                  <a:srgbClr val="1C2733"/>
                 </a:solidFill>
                 <a:latin typeface="Consolas"/>
               </a:rPr>
@@ -4678,7 +4678,7 @@
       </p:sp>
       <p:sp>
         <p:nvSpPr>
-          <p:cNvPr id="5" name="Rounded Rectangle 4"/>
+          <p:cNvPr id="5" name="Rectangle 4"/>
           <p:cNvSpPr/>
           <p:nvPr/>
         </p:nvSpPr>
@@ -4687,15 +4687,15 @@
             <a:off x="6903720" y="1691640"/>
             <a:ext cx="4663440" cy="3977639"/>
           </a:xfrm>
-          <a:prstGeom prst="roundRect">
+          <a:prstGeom prst="rect">
             <a:avLst/>
           </a:prstGeom>
           <a:solidFill>
-            <a:srgbClr val="F6ECD6"/>
+            <a:srgbClr val="F2EBDE"/>
           </a:solidFill>
           <a:ln w="9525">
             <a:solidFill>
-              <a:srgbClr val="D9DFE5"/>
+              <a:srgbClr val="D5DBE1"/>
             </a:solidFill>
           </a:ln>
           <a:effectLst/>
@@ -4726,7 +4726,7 @@
             <a:r>
               <a:rPr sz="1250" b="1">
                 <a:solidFill>
-                  <a:srgbClr val="A96E12"/>
+                  <a:srgbClr val="8A5A1B"/>
                 </a:solidFill>
                 <a:latin typeface="Segoe UI"/>
               </a:rPr>
@@ -4742,7 +4742,7 @@
             <a:r>
               <a:rPr sz="1050" b="0">
                 <a:solidFill>
-                  <a:srgbClr val="0A5B55"/>
+                  <a:srgbClr val="122A42"/>
                 </a:solidFill>
                 <a:latin typeface="Consolas"/>
               </a:rPr>
@@ -4758,7 +4758,7 @@
             <a:r>
               <a:rPr sz="1050" b="0">
                 <a:solidFill>
-                  <a:srgbClr val="A96E12"/>
+                  <a:srgbClr val="8A5A1B"/>
                 </a:solidFill>
                 <a:latin typeface="Consolas"/>
               </a:rPr>
@@ -4774,7 +4774,7 @@
             <a:r>
               <a:rPr sz="1050" b="0">
                 <a:solidFill>
-                  <a:srgbClr val="A96E12"/>
+                  <a:srgbClr val="8A5A1B"/>
                 </a:solidFill>
                 <a:latin typeface="Consolas"/>
               </a:rPr>
@@ -4790,7 +4790,7 @@
             <a:r>
               <a:rPr sz="1050" b="0">
                 <a:solidFill>
-                  <a:srgbClr val="0A5B55"/>
+                  <a:srgbClr val="122A42"/>
                 </a:solidFill>
                 <a:latin typeface="Consolas"/>
               </a:rPr>
@@ -4806,7 +4806,7 @@
             <a:r>
               <a:rPr sz="1050" b="0">
                 <a:solidFill>
-                  <a:srgbClr val="A96E12"/>
+                  <a:srgbClr val="8A5A1B"/>
                 </a:solidFill>
                 <a:latin typeface="Consolas"/>
               </a:rPr>
@@ -4822,7 +4822,7 @@
             <a:r>
               <a:rPr sz="1050" b="0">
                 <a:solidFill>
-                  <a:srgbClr val="A96E12"/>
+                  <a:srgbClr val="8A5A1B"/>
                 </a:solidFill>
                 <a:latin typeface="Consolas"/>
               </a:rPr>
@@ -4838,7 +4838,7 @@
             <a:r>
               <a:rPr sz="1050" b="0">
                 <a:solidFill>
-                  <a:srgbClr val="A96E12"/>
+                  <a:srgbClr val="8A5A1B"/>
                 </a:solidFill>
                 <a:latin typeface="Consolas"/>
               </a:rPr>
@@ -4854,7 +4854,7 @@
             <a:r>
               <a:rPr sz="1050" b="0">
                 <a:solidFill>
-                  <a:srgbClr val="A96E12"/>
+                  <a:srgbClr val="8A5A1B"/>
                 </a:solidFill>
                 <a:latin typeface="Consolas"/>
               </a:rPr>
@@ -4870,7 +4870,7 @@
             <a:r>
               <a:rPr sz="1050" b="0">
                 <a:solidFill>
-                  <a:srgbClr val="1A1F27"/>
+                  <a:srgbClr val="1C2733"/>
                 </a:solidFill>
                 <a:latin typeface="Segoe UI"/>
               </a:rPr>
@@ -4886,7 +4886,7 @@
             <a:r>
               <a:rPr sz="1050" b="0">
                 <a:solidFill>
-                  <a:srgbClr val="2E8B5E"/>
+                  <a:srgbClr val="2F6E4E"/>
                 </a:solidFill>
                 <a:latin typeface="Segoe UI"/>
               </a:rPr>
@@ -4902,7 +4902,7 @@
             <a:r>
               <a:rPr sz="1050" b="0">
                 <a:solidFill>
-                  <a:srgbClr val="2E8B5E"/>
+                  <a:srgbClr val="2F6E4E"/>
                 </a:solidFill>
                 <a:latin typeface="Segoe UI"/>
               </a:rPr>
@@ -4913,7 +4913,7 @@
       </p:sp>
       <p:sp>
         <p:nvSpPr>
-          <p:cNvPr id="6" name="Rounded Rectangle 5"/>
+          <p:cNvPr id="6" name="Rectangle 5"/>
           <p:cNvSpPr/>
           <p:nvPr/>
         </p:nvSpPr>
@@ -4922,11 +4922,11 @@
             <a:off x="640080" y="5806440"/>
             <a:ext cx="10927080" cy="731520"/>
           </a:xfrm>
-          <a:prstGeom prst="roundRect">
+          <a:prstGeom prst="rect">
             <a:avLst/>
           </a:prstGeom>
           <a:solidFill>
-            <a:srgbClr val="E1F0EE"/>
+            <a:srgbClr val="EAEEF2"/>
           </a:solidFill>
           <a:ln>
             <a:noFill/>
@@ -4959,7 +4959,7 @@
             <a:r>
               <a:rPr sz="1350" b="1">
                 <a:solidFill>
-                  <a:srgbClr val="0A5B55"/>
+                  <a:srgbClr val="122A42"/>
                 </a:solidFill>
                 <a:latin typeface="Segoe UI"/>
               </a:rPr>
@@ -5009,7 +5009,7 @@
             <a:avLst/>
           </a:prstGeom>
           <a:solidFill>
-            <a:srgbClr val="0E7C74"/>
+            <a:srgbClr val="16324F"/>
           </a:solidFill>
           <a:ln>
             <a:noFill/>
@@ -5068,7 +5068,7 @@
             <a:r>
               <a:rPr sz="1200" b="1">
                 <a:solidFill>
-                  <a:srgbClr val="0E7C74"/>
+                  <a:srgbClr val="16324F"/>
                 </a:solidFill>
                 <a:latin typeface="Segoe UI"/>
               </a:rPr>
@@ -5084,7 +5084,7 @@
             <a:r>
               <a:rPr sz="2400" b="1">
                 <a:solidFill>
-                  <a:srgbClr val="1A1F27"/>
+                  <a:srgbClr val="1C2733"/>
                 </a:solidFill>
                 <a:latin typeface="Segoe UI"/>
               </a:rPr>
@@ -5136,7 +5136,7 @@
                   </a:txBody>
                   <a:tcPr anchor="ctr" marL="82296" marR="45720" marT="18288" marB="18288">
                     <a:solidFill>
-                      <a:srgbClr val="0E7C74"/>
+                      <a:srgbClr val="16324F"/>
                     </a:solidFill>
                   </a:tcPr>
                 </a:tc>
@@ -5158,7 +5158,7 @@
                   </a:txBody>
                   <a:tcPr anchor="ctr" marL="82296" marR="45720" marT="18288" marB="18288">
                     <a:solidFill>
-                      <a:srgbClr val="0E7C74"/>
+                      <a:srgbClr val="16324F"/>
                     </a:solidFill>
                   </a:tcPr>
                 </a:tc>
@@ -5180,7 +5180,7 @@
                   </a:txBody>
                   <a:tcPr anchor="ctr" marL="82296" marR="45720" marT="18288" marB="18288">
                     <a:solidFill>
-                      <a:srgbClr val="0E7C74"/>
+                      <a:srgbClr val="16324F"/>
                     </a:solidFill>
                   </a:tcPr>
                 </a:tc>
@@ -5202,7 +5202,7 @@
                   </a:txBody>
                   <a:tcPr anchor="ctr" marL="82296" marR="45720" marT="18288" marB="18288">
                     <a:solidFill>
-                      <a:srgbClr val="0E7C74"/>
+                      <a:srgbClr val="16324F"/>
                     </a:solidFill>
                   </a:tcPr>
                 </a:tc>
@@ -5216,7 +5216,7 @@
                       <a:r>
                         <a:rPr sz="1250" b="1">
                           <a:solidFill>
-                            <a:srgbClr val="1A1F27"/>
+                            <a:srgbClr val="1C2733"/>
                           </a:solidFill>
                           <a:latin typeface="Segoe UI"/>
                         </a:rPr>
@@ -5238,7 +5238,7 @@
                       <a:r>
                         <a:rPr sz="1250" b="0">
                           <a:solidFill>
-                            <a:srgbClr val="535C6A"/>
+                            <a:srgbClr val="566573"/>
                           </a:solidFill>
                           <a:latin typeface="Consolas"/>
                         </a:rPr>
@@ -5260,7 +5260,7 @@
                       <a:r>
                         <a:rPr sz="1250" b="0">
                           <a:solidFill>
-                            <a:srgbClr val="535C6A"/>
+                            <a:srgbClr val="566573"/>
                           </a:solidFill>
                           <a:latin typeface="Consolas"/>
                         </a:rPr>
@@ -5282,7 +5282,7 @@
                       <a:r>
                         <a:rPr sz="1250" b="0">
                           <a:solidFill>
-                            <a:srgbClr val="535C6A"/>
+                            <a:srgbClr val="566573"/>
                           </a:solidFill>
                           <a:latin typeface="Consolas"/>
                         </a:rPr>
@@ -5306,7 +5306,7 @@
                       <a:r>
                         <a:rPr sz="1250" b="1">
                           <a:solidFill>
-                            <a:srgbClr val="1A1F27"/>
+                            <a:srgbClr val="1C2733"/>
                           </a:solidFill>
                           <a:latin typeface="Segoe UI"/>
                         </a:rPr>
@@ -5316,7 +5316,7 @@
                   </a:txBody>
                   <a:tcPr anchor="ctr" marL="82296" marR="45720" marT="18288" marB="18288">
                     <a:solidFill>
-                      <a:srgbClr val="F7F9F8"/>
+                      <a:srgbClr val="F6F8FA"/>
                     </a:solidFill>
                   </a:tcPr>
                 </a:tc>
@@ -5328,7 +5328,7 @@
                       <a:r>
                         <a:rPr sz="1250" b="0">
                           <a:solidFill>
-                            <a:srgbClr val="535C6A"/>
+                            <a:srgbClr val="566573"/>
                           </a:solidFill>
                           <a:latin typeface="Consolas"/>
                         </a:rPr>
@@ -5338,7 +5338,7 @@
                   </a:txBody>
                   <a:tcPr anchor="ctr" marL="82296" marR="45720" marT="18288" marB="18288">
                     <a:solidFill>
-                      <a:srgbClr val="F7F9F8"/>
+                      <a:srgbClr val="F6F8FA"/>
                     </a:solidFill>
                   </a:tcPr>
                 </a:tc>
@@ -5350,7 +5350,7 @@
                       <a:r>
                         <a:rPr sz="1250" b="0">
                           <a:solidFill>
-                            <a:srgbClr val="535C6A"/>
+                            <a:srgbClr val="566573"/>
                           </a:solidFill>
                           <a:latin typeface="Consolas"/>
                         </a:rPr>
@@ -5360,7 +5360,7 @@
                   </a:txBody>
                   <a:tcPr anchor="ctr" marL="82296" marR="45720" marT="18288" marB="18288">
                     <a:solidFill>
-                      <a:srgbClr val="F7F9F8"/>
+                      <a:srgbClr val="F6F8FA"/>
                     </a:solidFill>
                   </a:tcPr>
                 </a:tc>
@@ -5372,7 +5372,7 @@
                       <a:r>
                         <a:rPr sz="1250" b="0">
                           <a:solidFill>
-                            <a:srgbClr val="535C6A"/>
+                            <a:srgbClr val="566573"/>
                           </a:solidFill>
                           <a:latin typeface="Consolas"/>
                         </a:rPr>
@@ -5382,7 +5382,7 @@
                   </a:txBody>
                   <a:tcPr anchor="ctr" marL="82296" marR="45720" marT="18288" marB="18288">
                     <a:solidFill>
-                      <a:srgbClr val="F7F9F8"/>
+                      <a:srgbClr val="F6F8FA"/>
                     </a:solidFill>
                   </a:tcPr>
                 </a:tc>
@@ -5396,7 +5396,7 @@
                       <a:r>
                         <a:rPr sz="1250" b="1">
                           <a:solidFill>
-                            <a:srgbClr val="1A1F27"/>
+                            <a:srgbClr val="1C2733"/>
                           </a:solidFill>
                           <a:latin typeface="Segoe UI"/>
                         </a:rPr>
@@ -5418,7 +5418,7 @@
                       <a:r>
                         <a:rPr sz="1250" b="0">
                           <a:solidFill>
-                            <a:srgbClr val="535C6A"/>
+                            <a:srgbClr val="566573"/>
                           </a:solidFill>
                           <a:latin typeface="Consolas"/>
                         </a:rPr>
@@ -5440,7 +5440,7 @@
                       <a:r>
                         <a:rPr sz="1250" b="0">
                           <a:solidFill>
-                            <a:srgbClr val="535C6A"/>
+                            <a:srgbClr val="566573"/>
                           </a:solidFill>
                           <a:latin typeface="Consolas"/>
                         </a:rPr>
@@ -5462,7 +5462,7 @@
                       <a:r>
                         <a:rPr sz="1250" b="0">
                           <a:solidFill>
-                            <a:srgbClr val="535C6A"/>
+                            <a:srgbClr val="566573"/>
                           </a:solidFill>
                           <a:latin typeface="Consolas"/>
                         </a:rPr>
@@ -5486,7 +5486,7 @@
                       <a:r>
                         <a:rPr sz="1250" b="1">
                           <a:solidFill>
-                            <a:srgbClr val="1A1F27"/>
+                            <a:srgbClr val="1C2733"/>
                           </a:solidFill>
                           <a:latin typeface="Segoe UI"/>
                         </a:rPr>
@@ -5496,7 +5496,7 @@
                   </a:txBody>
                   <a:tcPr anchor="ctr" marL="82296" marR="45720" marT="18288" marB="18288">
                     <a:solidFill>
-                      <a:srgbClr val="F7F9F8"/>
+                      <a:srgbClr val="F6F8FA"/>
                     </a:solidFill>
                   </a:tcPr>
                 </a:tc>
@@ -5508,7 +5508,7 @@
                       <a:r>
                         <a:rPr sz="1250" b="0">
                           <a:solidFill>
-                            <a:srgbClr val="535C6A"/>
+                            <a:srgbClr val="566573"/>
                           </a:solidFill>
                           <a:latin typeface="Consolas"/>
                         </a:rPr>
@@ -5518,7 +5518,7 @@
                   </a:txBody>
                   <a:tcPr anchor="ctr" marL="82296" marR="45720" marT="18288" marB="18288">
                     <a:solidFill>
-                      <a:srgbClr val="F7F9F8"/>
+                      <a:srgbClr val="F6F8FA"/>
                     </a:solidFill>
                   </a:tcPr>
                 </a:tc>
@@ -5530,7 +5530,7 @@
                       <a:r>
                         <a:rPr sz="1250" b="0">
                           <a:solidFill>
-                            <a:srgbClr val="535C6A"/>
+                            <a:srgbClr val="566573"/>
                           </a:solidFill>
                           <a:latin typeface="Consolas"/>
                         </a:rPr>
@@ -5540,7 +5540,7 @@
                   </a:txBody>
                   <a:tcPr anchor="ctr" marL="82296" marR="45720" marT="18288" marB="18288">
                     <a:solidFill>
-                      <a:srgbClr val="F7F9F8"/>
+                      <a:srgbClr val="F6F8FA"/>
                     </a:solidFill>
                   </a:tcPr>
                 </a:tc>
@@ -5552,7 +5552,7 @@
                       <a:r>
                         <a:rPr sz="1250" b="0">
                           <a:solidFill>
-                            <a:srgbClr val="535C6A"/>
+                            <a:srgbClr val="566573"/>
                           </a:solidFill>
                           <a:latin typeface="Consolas"/>
                         </a:rPr>
@@ -5562,7 +5562,7 @@
                   </a:txBody>
                   <a:tcPr anchor="ctr" marL="82296" marR="45720" marT="18288" marB="18288">
                     <a:solidFill>
-                      <a:srgbClr val="F7F9F8"/>
+                      <a:srgbClr val="F6F8FA"/>
                     </a:solidFill>
                   </a:tcPr>
                 </a:tc>
@@ -5576,7 +5576,7 @@
                       <a:r>
                         <a:rPr sz="1250" b="1">
                           <a:solidFill>
-                            <a:srgbClr val="1A1F27"/>
+                            <a:srgbClr val="1C2733"/>
                           </a:solidFill>
                           <a:latin typeface="Segoe UI"/>
                         </a:rPr>
@@ -5598,7 +5598,7 @@
                       <a:r>
                         <a:rPr sz="1250" b="0">
                           <a:solidFill>
-                            <a:srgbClr val="535C6A"/>
+                            <a:srgbClr val="566573"/>
                           </a:solidFill>
                           <a:latin typeface="Consolas"/>
                         </a:rPr>
@@ -5620,7 +5620,7 @@
                       <a:r>
                         <a:rPr sz="1250" b="0">
                           <a:solidFill>
-                            <a:srgbClr val="535C6A"/>
+                            <a:srgbClr val="566573"/>
                           </a:solidFill>
                           <a:latin typeface="Consolas"/>
                         </a:rPr>
@@ -5642,7 +5642,7 @@
                       <a:r>
                         <a:rPr sz="1250" b="0">
                           <a:solidFill>
-                            <a:srgbClr val="535C6A"/>
+                            <a:srgbClr val="566573"/>
                           </a:solidFill>
                           <a:latin typeface="Consolas"/>
                         </a:rPr>
@@ -5666,7 +5666,7 @@
                       <a:r>
                         <a:rPr sz="1250" b="1">
                           <a:solidFill>
-                            <a:srgbClr val="1A1F27"/>
+                            <a:srgbClr val="1C2733"/>
                           </a:solidFill>
                           <a:latin typeface="Segoe UI"/>
                         </a:rPr>
@@ -5676,7 +5676,7 @@
                   </a:txBody>
                   <a:tcPr anchor="ctr" marL="82296" marR="45720" marT="18288" marB="18288">
                     <a:solidFill>
-                      <a:srgbClr val="F7F9F8"/>
+                      <a:srgbClr val="F6F8FA"/>
                     </a:solidFill>
                   </a:tcPr>
                 </a:tc>
@@ -5688,7 +5688,7 @@
                       <a:r>
                         <a:rPr sz="1250" b="0">
                           <a:solidFill>
-                            <a:srgbClr val="535C6A"/>
+                            <a:srgbClr val="566573"/>
                           </a:solidFill>
                           <a:latin typeface="Consolas"/>
                         </a:rPr>
@@ -5698,7 +5698,7 @@
                   </a:txBody>
                   <a:tcPr anchor="ctr" marL="82296" marR="45720" marT="18288" marB="18288">
                     <a:solidFill>
-                      <a:srgbClr val="F7F9F8"/>
+                      <a:srgbClr val="F6F8FA"/>
                     </a:solidFill>
                   </a:tcPr>
                 </a:tc>
@@ -5710,7 +5710,7 @@
                       <a:r>
                         <a:rPr sz="1250" b="0">
                           <a:solidFill>
-                            <a:srgbClr val="535C6A"/>
+                            <a:srgbClr val="566573"/>
                           </a:solidFill>
                           <a:latin typeface="Consolas"/>
                         </a:rPr>
@@ -5720,7 +5720,7 @@
                   </a:txBody>
                   <a:tcPr anchor="ctr" marL="82296" marR="45720" marT="18288" marB="18288">
                     <a:solidFill>
-                      <a:srgbClr val="F7F9F8"/>
+                      <a:srgbClr val="F6F8FA"/>
                     </a:solidFill>
                   </a:tcPr>
                 </a:tc>
@@ -5732,7 +5732,7 @@
                       <a:r>
                         <a:rPr sz="1250" b="0">
                           <a:solidFill>
-                            <a:srgbClr val="535C6A"/>
+                            <a:srgbClr val="566573"/>
                           </a:solidFill>
                           <a:latin typeface="Consolas"/>
                         </a:rPr>
@@ -5742,7 +5742,7 @@
                   </a:txBody>
                   <a:tcPr anchor="ctr" marL="82296" marR="45720" marT="18288" marB="18288">
                     <a:solidFill>
-                      <a:srgbClr val="F7F9F8"/>
+                      <a:srgbClr val="F6F8FA"/>
                     </a:solidFill>
                   </a:tcPr>
                 </a:tc>
@@ -5756,7 +5756,7 @@
                       <a:r>
                         <a:rPr sz="1250" b="1">
                           <a:solidFill>
-                            <a:srgbClr val="1A1F27"/>
+                            <a:srgbClr val="1C2733"/>
                           </a:solidFill>
                           <a:latin typeface="Segoe UI"/>
                         </a:rPr>
@@ -5778,7 +5778,7 @@
                       <a:r>
                         <a:rPr sz="1250" b="0">
                           <a:solidFill>
-                            <a:srgbClr val="535C6A"/>
+                            <a:srgbClr val="566573"/>
                           </a:solidFill>
                           <a:latin typeface="Consolas"/>
                         </a:rPr>
@@ -5800,7 +5800,7 @@
                       <a:r>
                         <a:rPr sz="1250" b="0">
                           <a:solidFill>
-                            <a:srgbClr val="535C6A"/>
+                            <a:srgbClr val="566573"/>
                           </a:solidFill>
                           <a:latin typeface="Consolas"/>
                         </a:rPr>
@@ -5822,7 +5822,7 @@
                       <a:r>
                         <a:rPr sz="1250" b="0">
                           <a:solidFill>
-                            <a:srgbClr val="535C6A"/>
+                            <a:srgbClr val="566573"/>
                           </a:solidFill>
                           <a:latin typeface="Consolas"/>
                         </a:rPr>
@@ -5843,7 +5843,7 @@
       </p:graphicFrame>
       <p:sp>
         <p:nvSpPr>
-          <p:cNvPr id="5" name="Rounded Rectangle 4"/>
+          <p:cNvPr id="5" name="Rectangle 4"/>
           <p:cNvSpPr/>
           <p:nvPr/>
         </p:nvSpPr>
@@ -5852,11 +5852,11 @@
             <a:off x="640080" y="5806440"/>
             <a:ext cx="10927080" cy="777240"/>
           </a:xfrm>
-          <a:prstGeom prst="roundRect">
+          <a:prstGeom prst="rect">
             <a:avLst/>
           </a:prstGeom>
           <a:solidFill>
-            <a:srgbClr val="E1F0EE"/>
+            <a:srgbClr val="EAEEF2"/>
           </a:solidFill>
           <a:ln>
             <a:noFill/>
@@ -5889,7 +5889,7 @@
             <a:r>
               <a:rPr sz="1400" b="1">
                 <a:solidFill>
-                  <a:srgbClr val="0A5B55"/>
+                  <a:srgbClr val="122A42"/>
                 </a:solidFill>
                 <a:latin typeface="Segoe UI"/>
               </a:rPr>
@@ -5939,7 +5939,7 @@
             <a:avLst/>
           </a:prstGeom>
           <a:solidFill>
-            <a:srgbClr val="0E7C74"/>
+            <a:srgbClr val="16324F"/>
           </a:solidFill>
           <a:ln>
             <a:noFill/>
@@ -5998,7 +5998,7 @@
             <a:r>
               <a:rPr sz="1200" b="1">
                 <a:solidFill>
-                  <a:srgbClr val="0E7C74"/>
+                  <a:srgbClr val="16324F"/>
                 </a:solidFill>
                 <a:latin typeface="Segoe UI"/>
               </a:rPr>
@@ -6014,7 +6014,7 @@
             <a:r>
               <a:rPr sz="2400" b="1">
                 <a:solidFill>
-                  <a:srgbClr val="1A1F27"/>
+                  <a:srgbClr val="1C2733"/>
                 </a:solidFill>
                 <a:latin typeface="Segoe UI"/>
               </a:rPr>
@@ -6067,7 +6067,7 @@
                   </a:txBody>
                   <a:tcPr anchor="ctr" marL="82296" marR="45720" marT="18288" marB="18288">
                     <a:solidFill>
-                      <a:srgbClr val="0E7C74"/>
+                      <a:srgbClr val="16324F"/>
                     </a:solidFill>
                   </a:tcPr>
                 </a:tc>
@@ -6089,7 +6089,7 @@
                   </a:txBody>
                   <a:tcPr anchor="ctr" marL="82296" marR="45720" marT="18288" marB="18288">
                     <a:solidFill>
-                      <a:srgbClr val="0E7C74"/>
+                      <a:srgbClr val="16324F"/>
                     </a:solidFill>
                   </a:tcPr>
                 </a:tc>
@@ -6111,7 +6111,7 @@
                   </a:txBody>
                   <a:tcPr anchor="ctr" marL="82296" marR="45720" marT="18288" marB="18288">
                     <a:solidFill>
-                      <a:srgbClr val="0E7C74"/>
+                      <a:srgbClr val="16324F"/>
                     </a:solidFill>
                   </a:tcPr>
                 </a:tc>
@@ -6133,7 +6133,7 @@
                   </a:txBody>
                   <a:tcPr anchor="ctr" marL="82296" marR="45720" marT="18288" marB="18288">
                     <a:solidFill>
-                      <a:srgbClr val="0E7C74"/>
+                      <a:srgbClr val="16324F"/>
                     </a:solidFill>
                   </a:tcPr>
                 </a:tc>
@@ -6155,7 +6155,7 @@
                   </a:txBody>
                   <a:tcPr anchor="ctr" marL="82296" marR="45720" marT="18288" marB="18288">
                     <a:solidFill>
-                      <a:srgbClr val="0E7C74"/>
+                      <a:srgbClr val="16324F"/>
                     </a:solidFill>
                   </a:tcPr>
                 </a:tc>
@@ -6169,7 +6169,7 @@
                       <a:r>
                         <a:rPr sz="1250" b="1">
                           <a:solidFill>
-                            <a:srgbClr val="1A1F27"/>
+                            <a:srgbClr val="1C2733"/>
                           </a:solidFill>
                           <a:latin typeface="Segoe UI"/>
                         </a:rPr>
@@ -6191,7 +6191,7 @@
                       <a:r>
                         <a:rPr sz="1250" b="0">
                           <a:solidFill>
-                            <a:srgbClr val="535C6A"/>
+                            <a:srgbClr val="566573"/>
                           </a:solidFill>
                           <a:latin typeface="Consolas"/>
                         </a:rPr>
@@ -6213,7 +6213,7 @@
                       <a:r>
                         <a:rPr sz="1250" b="0">
                           <a:solidFill>
-                            <a:srgbClr val="535C6A"/>
+                            <a:srgbClr val="566573"/>
                           </a:solidFill>
                           <a:latin typeface="Consolas"/>
                         </a:rPr>
@@ -6235,7 +6235,7 @@
                       <a:r>
                         <a:rPr sz="1250" b="0">
                           <a:solidFill>
-                            <a:srgbClr val="535C6A"/>
+                            <a:srgbClr val="566573"/>
                           </a:solidFill>
                           <a:latin typeface="Consolas"/>
                         </a:rPr>
@@ -6257,7 +6257,7 @@
                       <a:r>
                         <a:rPr sz="1250" b="0">
                           <a:solidFill>
-                            <a:srgbClr val="535C6A"/>
+                            <a:srgbClr val="566573"/>
                           </a:solidFill>
                           <a:latin typeface="Consolas"/>
                         </a:rPr>
@@ -6281,7 +6281,7 @@
                       <a:r>
                         <a:rPr sz="1250" b="1">
                           <a:solidFill>
-                            <a:srgbClr val="1A1F27"/>
+                            <a:srgbClr val="1C2733"/>
                           </a:solidFill>
                           <a:latin typeface="Segoe UI"/>
                         </a:rPr>
@@ -6291,7 +6291,7 @@
                   </a:txBody>
                   <a:tcPr anchor="ctr" marL="82296" marR="45720" marT="18288" marB="18288">
                     <a:solidFill>
-                      <a:srgbClr val="F7F9F8"/>
+                      <a:srgbClr val="F6F8FA"/>
                     </a:solidFill>
                   </a:tcPr>
                 </a:tc>
@@ -6303,7 +6303,7 @@
                       <a:r>
                         <a:rPr sz="1250" b="0">
                           <a:solidFill>
-                            <a:srgbClr val="535C6A"/>
+                            <a:srgbClr val="566573"/>
                           </a:solidFill>
                           <a:latin typeface="Consolas"/>
                         </a:rPr>
@@ -6313,7 +6313,7 @@
                   </a:txBody>
                   <a:tcPr anchor="ctr" marL="82296" marR="45720" marT="18288" marB="18288">
                     <a:solidFill>
-                      <a:srgbClr val="F7F9F8"/>
+                      <a:srgbClr val="F6F8FA"/>
                     </a:solidFill>
                   </a:tcPr>
                 </a:tc>
@@ -6325,7 +6325,7 @@
                       <a:r>
                         <a:rPr sz="1250" b="0">
                           <a:solidFill>
-                            <a:srgbClr val="535C6A"/>
+                            <a:srgbClr val="566573"/>
                           </a:solidFill>
                           <a:latin typeface="Consolas"/>
                         </a:rPr>
@@ -6335,7 +6335,7 @@
                   </a:txBody>
                   <a:tcPr anchor="ctr" marL="82296" marR="45720" marT="18288" marB="18288">
                     <a:solidFill>
-                      <a:srgbClr val="F7F9F8"/>
+                      <a:srgbClr val="F6F8FA"/>
                     </a:solidFill>
                   </a:tcPr>
                 </a:tc>
@@ -6347,7 +6347,7 @@
                       <a:r>
                         <a:rPr sz="1250" b="0">
                           <a:solidFill>
-                            <a:srgbClr val="535C6A"/>
+                            <a:srgbClr val="566573"/>
                           </a:solidFill>
                           <a:latin typeface="Consolas"/>
                         </a:rPr>
@@ -6357,7 +6357,7 @@
                   </a:txBody>
                   <a:tcPr anchor="ctr" marL="82296" marR="45720" marT="18288" marB="18288">
                     <a:solidFill>
-                      <a:srgbClr val="F7F9F8"/>
+                      <a:srgbClr val="F6F8FA"/>
                     </a:solidFill>
                   </a:tcPr>
                 </a:tc>
@@ -6369,7 +6369,7 @@
                       <a:r>
                         <a:rPr sz="1250" b="0">
                           <a:solidFill>
-                            <a:srgbClr val="535C6A"/>
+                            <a:srgbClr val="566573"/>
                           </a:solidFill>
                           <a:latin typeface="Consolas"/>
                         </a:rPr>
@@ -6379,7 +6379,7 @@
                   </a:txBody>
                   <a:tcPr anchor="ctr" marL="82296" marR="45720" marT="18288" marB="18288">
                     <a:solidFill>
-                      <a:srgbClr val="F7F9F8"/>
+                      <a:srgbClr val="F6F8FA"/>
                     </a:solidFill>
                   </a:tcPr>
                 </a:tc>
@@ -6393,7 +6393,7 @@
                       <a:r>
                         <a:rPr sz="1250" b="1">
                           <a:solidFill>
-                            <a:srgbClr val="1A1F27"/>
+                            <a:srgbClr val="1C2733"/>
                           </a:solidFill>
                           <a:latin typeface="Segoe UI"/>
                         </a:rPr>
@@ -6415,7 +6415,7 @@
                       <a:r>
                         <a:rPr sz="1250" b="0">
                           <a:solidFill>
-                            <a:srgbClr val="535C6A"/>
+                            <a:srgbClr val="566573"/>
                           </a:solidFill>
                           <a:latin typeface="Consolas"/>
                         </a:rPr>
@@ -6437,7 +6437,7 @@
                       <a:r>
                         <a:rPr sz="1250" b="0">
                           <a:solidFill>
-                            <a:srgbClr val="535C6A"/>
+                            <a:srgbClr val="566573"/>
                           </a:solidFill>
                           <a:latin typeface="Consolas"/>
                         </a:rPr>
@@ -6459,7 +6459,7 @@
                       <a:r>
                         <a:rPr sz="1250" b="0">
                           <a:solidFill>
-                            <a:srgbClr val="535C6A"/>
+                            <a:srgbClr val="566573"/>
                           </a:solidFill>
                           <a:latin typeface="Consolas"/>
                         </a:rPr>
@@ -6481,7 +6481,7 @@
                       <a:r>
                         <a:rPr sz="1250" b="0">
                           <a:solidFill>
-                            <a:srgbClr val="535C6A"/>
+                            <a:srgbClr val="566573"/>
                           </a:solidFill>
                           <a:latin typeface="Consolas"/>
                         </a:rPr>
@@ -6502,7 +6502,7 @@
       </p:graphicFrame>
       <p:sp>
         <p:nvSpPr>
-          <p:cNvPr id="5" name="Rounded Rectangle 4"/>
+          <p:cNvPr id="5" name="Rectangle 4"/>
           <p:cNvSpPr/>
           <p:nvPr/>
         </p:nvSpPr>
@@ -6511,11 +6511,11 @@
             <a:off x="640080" y="5852160"/>
             <a:ext cx="10927080" cy="749808"/>
           </a:xfrm>
-          <a:prstGeom prst="roundRect">
+          <a:prstGeom prst="rect">
             <a:avLst/>
           </a:prstGeom>
           <a:solidFill>
-            <a:srgbClr val="E1F0EE"/>
+            <a:srgbClr val="EAEEF2"/>
           </a:solidFill>
           <a:ln>
             <a:noFill/>
@@ -6548,7 +6548,7 @@
             <a:r>
               <a:rPr sz="1350" b="1">
                 <a:solidFill>
-                  <a:srgbClr val="0A5B55"/>
+                  <a:srgbClr val="122A42"/>
                 </a:solidFill>
                 <a:latin typeface="Segoe UI"/>
               </a:rPr>
@@ -6598,7 +6598,7 @@
             <a:avLst/>
           </a:prstGeom>
           <a:solidFill>
-            <a:srgbClr val="0E7C74"/>
+            <a:srgbClr val="16324F"/>
           </a:solidFill>
           <a:ln>
             <a:noFill/>
@@ -6657,7 +6657,7 @@
             <a:r>
               <a:rPr sz="1200" b="1">
                 <a:solidFill>
-                  <a:srgbClr val="0E7C74"/>
+                  <a:srgbClr val="16324F"/>
                 </a:solidFill>
                 <a:latin typeface="Segoe UI"/>
               </a:rPr>
@@ -6673,7 +6673,7 @@
             <a:r>
               <a:rPr sz="2400" b="1">
                 <a:solidFill>
-                  <a:srgbClr val="1A1F27"/>
+                  <a:srgbClr val="1C2733"/>
                 </a:solidFill>
                 <a:latin typeface="Segoe UI"/>
               </a:rPr>
@@ -6712,7 +6712,7 @@
             <a:r>
               <a:rPr sz="1350" b="0">
                 <a:solidFill>
-                  <a:srgbClr val="1A1F27"/>
+                  <a:srgbClr val="1C2733"/>
                 </a:solidFill>
                 <a:latin typeface="Segoe UI"/>
               </a:rPr>
@@ -6728,7 +6728,7 @@
             <a:r>
               <a:rPr sz="1350" b="0">
                 <a:solidFill>
-                  <a:srgbClr val="1A1F27"/>
+                  <a:srgbClr val="1C2733"/>
                 </a:solidFill>
                 <a:latin typeface="Segoe UI"/>
               </a:rPr>
@@ -6744,7 +6744,7 @@
             <a:r>
               <a:rPr sz="1350" b="0">
                 <a:solidFill>
-                  <a:srgbClr val="1A1F27"/>
+                  <a:srgbClr val="1C2733"/>
                 </a:solidFill>
                 <a:latin typeface="Segoe UI"/>
               </a:rPr>
@@ -6760,7 +6760,7 @@
             <a:r>
               <a:rPr sz="1350" b="0">
                 <a:solidFill>
-                  <a:srgbClr val="A96E12"/>
+                  <a:srgbClr val="8A5A1B"/>
                 </a:solidFill>
                 <a:latin typeface="Segoe UI"/>
               </a:rPr>
@@ -6776,7 +6776,7 @@
             <a:r>
               <a:rPr sz="1350" b="0">
                 <a:solidFill>
-                  <a:srgbClr val="535C6A"/>
+                  <a:srgbClr val="566573"/>
                 </a:solidFill>
                 <a:latin typeface="Segoe UI"/>
               </a:rPr>
@@ -6792,7 +6792,7 @@
             <a:r>
               <a:rPr sz="1350" b="0">
                 <a:solidFill>
-                  <a:srgbClr val="2E8B5E"/>
+                  <a:srgbClr val="2F6E4E"/>
                 </a:solidFill>
                 <a:latin typeface="Segoe UI"/>
               </a:rPr>
@@ -6808,7 +6808,7 @@
             <a:r>
               <a:rPr sz="1350" b="0">
                 <a:solidFill>
-                  <a:srgbClr val="535C6A"/>
+                  <a:srgbClr val="566573"/>
                 </a:solidFill>
                 <a:latin typeface="Segoe UI"/>
               </a:rPr>
@@ -6819,7 +6819,7 @@
       </p:sp>
       <p:sp>
         <p:nvSpPr>
-          <p:cNvPr id="5" name="Rounded Rectangle 4"/>
+          <p:cNvPr id="5" name="Rectangle 4"/>
           <p:cNvSpPr/>
           <p:nvPr/>
         </p:nvSpPr>
@@ -6828,15 +6828,15 @@
             <a:off x="6400800" y="1737360"/>
             <a:ext cx="5166360" cy="2651760"/>
           </a:xfrm>
-          <a:prstGeom prst="roundRect">
+          <a:prstGeom prst="rect">
             <a:avLst/>
           </a:prstGeom>
           <a:solidFill>
-            <a:srgbClr val="F3F1EA"/>
+            <a:srgbClr val="F3F1EC"/>
           </a:solidFill>
           <a:ln w="9525">
             <a:solidFill>
-              <a:srgbClr val="D9DFE5"/>
+              <a:srgbClr val="D5DBE1"/>
             </a:solidFill>
           </a:ln>
           <a:effectLst/>
@@ -6867,7 +6867,7 @@
             <a:r>
               <a:rPr sz="1250" b="1">
                 <a:solidFill>
-                  <a:srgbClr val="0A5B55"/>
+                  <a:srgbClr val="122A42"/>
                 </a:solidFill>
                 <a:latin typeface="Segoe UI"/>
               </a:rPr>
@@ -6883,7 +6883,7 @@
             <a:r>
               <a:rPr sz="1050" b="0">
                 <a:solidFill>
-                  <a:srgbClr val="0A5B55"/>
+                  <a:srgbClr val="122A42"/>
                 </a:solidFill>
                 <a:latin typeface="Consolas"/>
               </a:rPr>
@@ -6899,7 +6899,7 @@
             <a:r>
               <a:rPr sz="1050" b="0">
                 <a:solidFill>
-                  <a:srgbClr val="0A5B55"/>
+                  <a:srgbClr val="122A42"/>
                 </a:solidFill>
                 <a:latin typeface="Consolas"/>
               </a:rPr>
@@ -6915,7 +6915,7 @@
             <a:r>
               <a:rPr sz="1050" b="0">
                 <a:solidFill>
-                  <a:srgbClr val="0A5B55"/>
+                  <a:srgbClr val="122A42"/>
                 </a:solidFill>
                 <a:latin typeface="Consolas"/>
               </a:rPr>
@@ -6931,7 +6931,7 @@
             <a:r>
               <a:rPr sz="1050" b="0">
                 <a:solidFill>
-                  <a:srgbClr val="0A5B55"/>
+                  <a:srgbClr val="122A42"/>
                 </a:solidFill>
                 <a:latin typeface="Consolas"/>
               </a:rPr>
@@ -6947,7 +6947,7 @@
             <a:r>
               <a:rPr sz="1050" b="0">
                 <a:solidFill>
-                  <a:srgbClr val="535C6A"/>
+                  <a:srgbClr val="566573"/>
                 </a:solidFill>
                 <a:latin typeface="Segoe UI"/>
               </a:rPr>
@@ -7000,7 +7000,7 @@
                   </a:txBody>
                   <a:tcPr anchor="ctr" marL="82296" marR="45720" marT="18288" marB="18288">
                     <a:solidFill>
-                      <a:srgbClr val="0E7C74"/>
+                      <a:srgbClr val="16324F"/>
                     </a:solidFill>
                   </a:tcPr>
                 </a:tc>
@@ -7022,7 +7022,7 @@
                   </a:txBody>
                   <a:tcPr anchor="ctr" marL="82296" marR="45720" marT="18288" marB="18288">
                     <a:solidFill>
-                      <a:srgbClr val="0E7C74"/>
+                      <a:srgbClr val="16324F"/>
                     </a:solidFill>
                   </a:tcPr>
                 </a:tc>
@@ -7044,7 +7044,7 @@
                   </a:txBody>
                   <a:tcPr anchor="ctr" marL="82296" marR="45720" marT="18288" marB="18288">
                     <a:solidFill>
-                      <a:srgbClr val="0E7C74"/>
+                      <a:srgbClr val="16324F"/>
                     </a:solidFill>
                   </a:tcPr>
                 </a:tc>
@@ -7066,7 +7066,7 @@
                   </a:txBody>
                   <a:tcPr anchor="ctr" marL="82296" marR="45720" marT="18288" marB="18288">
                     <a:solidFill>
-                      <a:srgbClr val="0E7C74"/>
+                      <a:srgbClr val="16324F"/>
                     </a:solidFill>
                   </a:tcPr>
                 </a:tc>
@@ -7088,7 +7088,7 @@
                   </a:txBody>
                   <a:tcPr anchor="ctr" marL="82296" marR="45720" marT="18288" marB="18288">
                     <a:solidFill>
-                      <a:srgbClr val="0E7C74"/>
+                      <a:srgbClr val="16324F"/>
                     </a:solidFill>
                   </a:tcPr>
                 </a:tc>
@@ -7102,7 +7102,7 @@
                       <a:r>
                         <a:rPr sz="1200" b="1">
                           <a:solidFill>
-                            <a:srgbClr val="1A1F27"/>
+                            <a:srgbClr val="1C2733"/>
                           </a:solidFill>
                           <a:latin typeface="Segoe UI"/>
                         </a:rPr>
@@ -7124,7 +7124,7 @@
                       <a:r>
                         <a:rPr sz="1200" b="0">
                           <a:solidFill>
-                            <a:srgbClr val="535C6A"/>
+                            <a:srgbClr val="566573"/>
                           </a:solidFill>
                           <a:latin typeface="Consolas"/>
                         </a:rPr>
@@ -7146,7 +7146,7 @@
                       <a:r>
                         <a:rPr sz="1200" b="0">
                           <a:solidFill>
-                            <a:srgbClr val="535C6A"/>
+                            <a:srgbClr val="566573"/>
                           </a:solidFill>
                           <a:latin typeface="Consolas"/>
                         </a:rPr>
@@ -7168,7 +7168,7 @@
                       <a:r>
                         <a:rPr sz="1200" b="0">
                           <a:solidFill>
-                            <a:srgbClr val="535C6A"/>
+                            <a:srgbClr val="566573"/>
                           </a:solidFill>
                           <a:latin typeface="Consolas"/>
                         </a:rPr>
@@ -7190,7 +7190,7 @@
                       <a:r>
                         <a:rPr sz="1200" b="0">
                           <a:solidFill>
-                            <a:srgbClr val="535C6A"/>
+                            <a:srgbClr val="566573"/>
                           </a:solidFill>
                           <a:latin typeface="Consolas"/>
                         </a:rPr>
@@ -7211,7 +7211,7 @@
       </p:graphicFrame>
       <p:sp>
         <p:nvSpPr>
-          <p:cNvPr id="7" name="Rounded Rectangle 6"/>
+          <p:cNvPr id="7" name="Rectangle 6"/>
           <p:cNvSpPr/>
           <p:nvPr/>
         </p:nvSpPr>
@@ -7220,11 +7220,11 @@
             <a:off x="640080" y="5806440"/>
             <a:ext cx="10927080" cy="749808"/>
           </a:xfrm>
-          <a:prstGeom prst="roundRect">
+          <a:prstGeom prst="rect">
             <a:avLst/>
           </a:prstGeom>
           <a:solidFill>
-            <a:srgbClr val="E1F0EE"/>
+            <a:srgbClr val="EAEEF2"/>
           </a:solidFill>
           <a:ln>
             <a:noFill/>
@@ -7257,7 +7257,7 @@
             <a:r>
               <a:rPr sz="1350" b="1">
                 <a:solidFill>
-                  <a:srgbClr val="0A5B55"/>
+                  <a:srgbClr val="122A42"/>
                 </a:solidFill>
                 <a:latin typeface="Segoe UI"/>
               </a:rPr>
@@ -7307,7 +7307,7 @@
             <a:avLst/>
           </a:prstGeom>
           <a:solidFill>
-            <a:srgbClr val="0E7C74"/>
+            <a:srgbClr val="16324F"/>
           </a:solidFill>
           <a:ln>
             <a:noFill/>
@@ -7366,7 +7366,7 @@
             <a:r>
               <a:rPr sz="1200" b="1">
                 <a:solidFill>
-                  <a:srgbClr val="0E7C74"/>
+                  <a:srgbClr val="16324F"/>
                 </a:solidFill>
                 <a:latin typeface="Segoe UI"/>
               </a:rPr>
@@ -7382,7 +7382,7 @@
             <a:r>
               <a:rPr sz="2400" b="1">
                 <a:solidFill>
-                  <a:srgbClr val="1A1F27"/>
+                  <a:srgbClr val="1C2733"/>
                 </a:solidFill>
                 <a:latin typeface="Segoe UI"/>
               </a:rPr>
@@ -7393,7 +7393,7 @@
       </p:sp>
       <p:sp>
         <p:nvSpPr>
-          <p:cNvPr id="4" name="Rounded Rectangle 3"/>
+          <p:cNvPr id="4" name="Rectangle 3"/>
           <p:cNvSpPr/>
           <p:nvPr/>
         </p:nvSpPr>
@@ -7402,15 +7402,15 @@
             <a:off x="640080" y="1737360"/>
             <a:ext cx="5486400" cy="2286000"/>
           </a:xfrm>
-          <a:prstGeom prst="roundRect">
+          <a:prstGeom prst="rect">
             <a:avLst/>
           </a:prstGeom>
           <a:solidFill>
-            <a:srgbClr val="E4F3EB"/>
+            <a:srgbClr val="E8F0EA"/>
           </a:solidFill>
           <a:ln w="9525">
             <a:solidFill>
-              <a:srgbClr val="D9DFE5"/>
+              <a:srgbClr val="D5DBE1"/>
             </a:solidFill>
           </a:ln>
           <a:effectLst/>
@@ -7441,7 +7441,7 @@
             <a:r>
               <a:rPr sz="1250" b="1">
                 <a:solidFill>
-                  <a:srgbClr val="2E8B5E"/>
+                  <a:srgbClr val="2F6E4E"/>
                 </a:solidFill>
                 <a:latin typeface="Segoe UI"/>
               </a:rPr>
@@ -7457,7 +7457,7 @@
             <a:r>
               <a:rPr sz="1150" b="0">
                 <a:solidFill>
-                  <a:srgbClr val="1A1F27"/>
+                  <a:srgbClr val="1C2733"/>
                 </a:solidFill>
                 <a:latin typeface="Segoe UI"/>
               </a:rPr>
@@ -7473,7 +7473,7 @@
             <a:r>
               <a:rPr sz="1150" b="0">
                 <a:solidFill>
-                  <a:srgbClr val="1A1F27"/>
+                  <a:srgbClr val="1C2733"/>
                 </a:solidFill>
                 <a:latin typeface="Segoe UI"/>
               </a:rPr>
@@ -7489,7 +7489,7 @@
             <a:r>
               <a:rPr sz="1150" b="0">
                 <a:solidFill>
-                  <a:srgbClr val="1A1F27"/>
+                  <a:srgbClr val="1C2733"/>
                 </a:solidFill>
                 <a:latin typeface="Segoe UI"/>
               </a:rPr>
@@ -7505,7 +7505,7 @@
             <a:r>
               <a:rPr sz="1150" b="0">
                 <a:solidFill>
-                  <a:srgbClr val="1A1F27"/>
+                  <a:srgbClr val="1C2733"/>
                 </a:solidFill>
                 <a:latin typeface="Segoe UI"/>
               </a:rPr>
@@ -7516,7 +7516,7 @@
       </p:sp>
       <p:sp>
         <p:nvSpPr>
-          <p:cNvPr id="5" name="Rounded Rectangle 4"/>
+          <p:cNvPr id="5" name="Rectangle 4"/>
           <p:cNvSpPr/>
           <p:nvPr/>
         </p:nvSpPr>
@@ -7525,15 +7525,15 @@
             <a:off x="6355080" y="1737360"/>
             <a:ext cx="5212080" cy="2286000"/>
           </a:xfrm>
-          <a:prstGeom prst="roundRect">
+          <a:prstGeom prst="rect">
             <a:avLst/>
           </a:prstGeom>
           <a:solidFill>
-            <a:srgbClr val="F6ECD6"/>
+            <a:srgbClr val="F2EBDE"/>
           </a:solidFill>
           <a:ln w="9525">
             <a:solidFill>
-              <a:srgbClr val="D9DFE5"/>
+              <a:srgbClr val="D5DBE1"/>
             </a:solidFill>
           </a:ln>
           <a:effectLst/>
@@ -7564,7 +7564,7 @@
             <a:r>
               <a:rPr sz="1250" b="1">
                 <a:solidFill>
-                  <a:srgbClr val="A96E12"/>
+                  <a:srgbClr val="8A5A1B"/>
                 </a:solidFill>
                 <a:latin typeface="Segoe UI"/>
               </a:rPr>
@@ -7580,7 +7580,7 @@
             <a:r>
               <a:rPr sz="1150" b="0">
                 <a:solidFill>
-                  <a:srgbClr val="1A1F27"/>
+                  <a:srgbClr val="1C2733"/>
                 </a:solidFill>
                 <a:latin typeface="Segoe UI"/>
               </a:rPr>
@@ -7596,7 +7596,7 @@
             <a:r>
               <a:rPr sz="1150" b="0">
                 <a:solidFill>
-                  <a:srgbClr val="1A1F27"/>
+                  <a:srgbClr val="1C2733"/>
                 </a:solidFill>
                 <a:latin typeface="Segoe UI"/>
               </a:rPr>
@@ -7612,7 +7612,7 @@
             <a:r>
               <a:rPr sz="1150" b="0">
                 <a:solidFill>
-                  <a:srgbClr val="1A1F27"/>
+                  <a:srgbClr val="1C2733"/>
                 </a:solidFill>
                 <a:latin typeface="Segoe UI"/>
               </a:rPr>
@@ -7628,7 +7628,7 @@
             <a:r>
               <a:rPr sz="1150" b="0">
                 <a:solidFill>
-                  <a:srgbClr val="1A1F27"/>
+                  <a:srgbClr val="1C2733"/>
                 </a:solidFill>
                 <a:latin typeface="Segoe UI"/>
               </a:rPr>
@@ -7678,7 +7678,7 @@
                   </a:txBody>
                   <a:tcPr anchor="ctr" marL="82296" marR="45720" marT="18288" marB="18288">
                     <a:solidFill>
-                      <a:srgbClr val="0E7C74"/>
+                      <a:srgbClr val="16324F"/>
                     </a:solidFill>
                   </a:tcPr>
                 </a:tc>
@@ -7700,7 +7700,7 @@
                   </a:txBody>
                   <a:tcPr anchor="ctr" marL="82296" marR="45720" marT="18288" marB="18288">
                     <a:solidFill>
-                      <a:srgbClr val="0E7C74"/>
+                      <a:srgbClr val="16324F"/>
                     </a:solidFill>
                   </a:tcPr>
                 </a:tc>
@@ -7714,7 +7714,7 @@
                       <a:r>
                         <a:rPr sz="1300" b="1">
                           <a:solidFill>
-                            <a:srgbClr val="1A1F27"/>
+                            <a:srgbClr val="1C2733"/>
                           </a:solidFill>
                           <a:latin typeface="Segoe UI"/>
                         </a:rPr>
@@ -7736,7 +7736,7 @@
                       <a:r>
                         <a:rPr sz="1300" b="0">
                           <a:solidFill>
-                            <a:srgbClr val="535C6A"/>
+                            <a:srgbClr val="566573"/>
                           </a:solidFill>
                           <a:latin typeface="Consolas"/>
                         </a:rPr>
@@ -7760,7 +7760,7 @@
                       <a:r>
                         <a:rPr sz="1300" b="1">
                           <a:solidFill>
-                            <a:srgbClr val="1A1F27"/>
+                            <a:srgbClr val="1C2733"/>
                           </a:solidFill>
                           <a:latin typeface="Segoe UI"/>
                         </a:rPr>
@@ -7770,7 +7770,7 @@
                   </a:txBody>
                   <a:tcPr anchor="ctr" marL="82296" marR="45720" marT="18288" marB="18288">
                     <a:solidFill>
-                      <a:srgbClr val="F7F9F8"/>
+                      <a:srgbClr val="F6F8FA"/>
                     </a:solidFill>
                   </a:tcPr>
                 </a:tc>
@@ -7782,7 +7782,7 @@
                       <a:r>
                         <a:rPr sz="1300" b="0">
                           <a:solidFill>
-                            <a:srgbClr val="535C6A"/>
+                            <a:srgbClr val="566573"/>
                           </a:solidFill>
                           <a:latin typeface="Consolas"/>
                         </a:rPr>
@@ -7792,7 +7792,7 @@
                   </a:txBody>
                   <a:tcPr anchor="ctr" marL="82296" marR="45720" marT="18288" marB="18288">
                     <a:solidFill>
-                      <a:srgbClr val="F7F9F8"/>
+                      <a:srgbClr val="F6F8FA"/>
                     </a:solidFill>
                   </a:tcPr>
                 </a:tc>
@@ -7806,7 +7806,7 @@
                       <a:r>
                         <a:rPr sz="1300" b="1">
                           <a:solidFill>
-                            <a:srgbClr val="1A1F27"/>
+                            <a:srgbClr val="1C2733"/>
                           </a:solidFill>
                           <a:latin typeface="Segoe UI"/>
                         </a:rPr>
@@ -7828,7 +7828,7 @@
                       <a:r>
                         <a:rPr sz="1300" b="0">
                           <a:solidFill>
-                            <a:srgbClr val="535C6A"/>
+                            <a:srgbClr val="566573"/>
                           </a:solidFill>
                           <a:latin typeface="Consolas"/>
                         </a:rPr>
@@ -7849,7 +7849,7 @@
       </p:graphicFrame>
       <p:sp>
         <p:nvSpPr>
-          <p:cNvPr id="7" name="Rounded Rectangle 6"/>
+          <p:cNvPr id="7" name="Rectangle 6"/>
           <p:cNvSpPr/>
           <p:nvPr/>
         </p:nvSpPr>
@@ -7858,11 +7858,11 @@
             <a:off x="640080" y="5943600"/>
             <a:ext cx="10927080" cy="658368"/>
           </a:xfrm>
-          <a:prstGeom prst="roundRect">
+          <a:prstGeom prst="rect">
             <a:avLst/>
           </a:prstGeom>
           <a:solidFill>
-            <a:srgbClr val="E1F0EE"/>
+            <a:srgbClr val="EAEEF2"/>
           </a:solidFill>
           <a:ln>
             <a:noFill/>
@@ -7895,7 +7895,7 @@
             <a:r>
               <a:rPr sz="1300" b="1">
                 <a:solidFill>
-                  <a:srgbClr val="0A5B55"/>
+                  <a:srgbClr val="122A42"/>
                 </a:solidFill>
                 <a:latin typeface="Segoe UI"/>
               </a:rPr>

</xml_diff>